<commit_message>
presentations: captioned narrated decks for Books 02-08 (wip)
</commit_message>
<xml_diff>
--- a/presentations/b02-identity/B02_Identity_Narrated.pptx
+++ b/presentations/b02-identity/B02_Identity_Narrated.pptx
@@ -117,14 +117,14 @@
   <p:extLst>
     <p:ext uri="{521415D9-36F7-43E2-AB2F-B90AF26B5E84}">
       <p14:sectionLst xmlns:p14="http://schemas.microsoft.com/office/powerpoint/2010/main">
-        <p14:section name="Why identity matters" id="{36B658B9-63E0-0B5B-0BE2-A89FC06B46F9}">
+        <p14:section name="Why identity matters" id="{252D397D-F72B-6D7A-7C8D-65F278D89D7E}">
           <p14:sldIdLst>
             <p14:sldId id="256"/>
             <p14:sldId id="257"/>
             <p14:sldId id="258"/>
           </p14:sldIdLst>
         </p14:section>
-        <p14:section name="What changes" id="{AB1D69BD-30C9-C07E-F211-FD3127E8A71D}">
+        <p14:section name="What changes" id="{55052109-6183-7980-B9CE-AA6E0993BC8C}">
           <p14:sldIdLst>
             <p14:sldId id="259"/>
             <p14:sldId id="260"/>
@@ -132,19 +132,19 @@
             <p14:sldId id="262"/>
           </p14:sldIdLst>
         </p14:section>
-        <p14:section name="Who owns it" id="{88D589CD-7428-5AC1-C542-92FC8E6E5E4F}">
+        <p14:section name="Who owns it" id="{F2A4C398-C262-7B73-F8D9-8BA02308393D}">
           <p14:sldIdLst>
             <p14:sldId id="263"/>
           </p14:sldIdLst>
         </p14:section>
-        <p14:section name="How to do it" id="{F2DF7BCD-7E6E-2685-7605-EB5DB27C59D9}">
+        <p14:section name="How to do it" id="{FB486A26-0329-F58A-BA66-8CBA11CFD0E4}">
           <p14:sldIdLst>
             <p14:sldId id="264"/>
             <p14:sldId id="265"/>
             <p14:sldId id="266"/>
           </p14:sldIdLst>
         </p14:section>
-        <p14:section name="Backup" id="{E0A784E4-1F72-8198-80D8-B40E0AA8FEDC}">
+        <p14:section name="Backup" id="{47BD790A-5004-4587-2BC3-D31C63DFD5AA}">
           <p14:sldIdLst/>
         </p14:section>
       </p14:sectionLst>
@@ -181,7 +181,7 @@
     </p:spTree>
     <p:extLst>
       <p:ext uri="{BB962C8B-B14F-4D97-AF65-F5344CB8AC3E}">
-        <p14:creationId xmlns:p14="http://schemas.microsoft.com/office/powerpoint/2010/main" val="832381334"/>
+        <p14:creationId xmlns:p14="http://schemas.microsoft.com/office/powerpoint/2010/main" val="215066518"/>
       </p:ext>
     </p:extLst>
   </p:cSld>
@@ -327,7 +327,7 @@
           <a:p>
             <a:r>
               <a:rPr lang="en-US" dirty="0"/>
-              <a:t>[0:00–0:29]  This briefing comes from Book 02 of the Modernization Workbook, Identity and Directory: the move from Active Directory to Entra ID.
+              <a:t>[0:00–0:29]  This briefing comes from Book 02 of the Federal Modernization Workbook, Identity and Directory: the move from Active Directory to Entra ID.
 I'll take it through four questions. Why identity matters now. What actually changes when a directory moves to the cloud. Who has to own which decisions. And how to do it without losing the governance that twenty-five years of Active Directory quietly carried.
 The short version: this is not a directory upgrade. It decides whether every security control after it works.
 Workbook: Book 02, index.</a:t>
@@ -1544,7 +1544,7 @@
                   <a:schemeClr val="accent5"/>
                 </a:solidFill>
               </a:rPr>
-              <a:t>Modernization Workbook  ·  Book 02 Identity &amp; Directory</a:t>
+              <a:t>Federal Modernization Workbook  ·  Book 02 Identity &amp; Directory</a:t>
             </a:r>
             <a:endParaRPr lang="en-US" sz="1000" dirty="0"/>
           </a:p>
@@ -2034,7 +2034,87 @@
       </p:sp>
       <p:sp>
         <p:nvSpPr>
-          <p:cNvPr id="4" name="Agenda line"/>
+          <p:cNvPr id="4" name="Presenter"/>
+          <p:cNvSpPr txBox="1"/>
+          <p:nvPr/>
+        </p:nvSpPr>
+        <p:spPr>
+          <a:xfrm>
+            <a:off x="731520" y="5897880"/>
+            <a:ext cx="6858000" cy="365760"/>
+          </a:xfrm>
+          <a:prstGeom prst="rect">
+            <a:avLst/>
+          </a:prstGeom>
+          <a:noFill/>
+          <a:ln/>
+        </p:spPr>
+        <p:txBody>
+          <a:bodyPr wrap="square" lIns="0" tIns="0" rIns="0" bIns="0" rtlCol="0" anchor="ctr"/>
+          <a:lstStyle/>
+          <a:p>
+            <a:pPr marL="0" indent="0">
+              <a:buNone/>
+            </a:pPr>
+            <a:r>
+              <a:rPr lang="en-US" sz="1600" dirty="0">
+                <a:solidFill>
+                  <a:srgbClr val="64748B"/>
+                </a:solidFill>
+              </a:rPr>
+              <a:t>Presented by  </a:t>
+            </a:r>
+            <a:r>
+              <a:rPr lang="en-US" sz="1600" b="1" dirty="0">
+                <a:solidFill>
+                  <a:srgbClr val="1F2A44"/>
+                </a:solidFill>
+              </a:rPr>
+              <a:t>Michael F. Stratton</a:t>
+            </a:r>
+            <a:endParaRPr lang="en-US" sz="1600" dirty="0"/>
+          </a:p>
+        </p:txBody>
+      </p:sp>
+      <p:sp>
+        <p:nvSpPr>
+          <p:cNvPr id="5" name="Disclaimer"/>
+          <p:cNvSpPr txBox="1"/>
+          <p:nvPr/>
+        </p:nvSpPr>
+        <p:spPr>
+          <a:xfrm>
+            <a:off x="731520" y="6309360"/>
+            <a:ext cx="8686800" cy="274320"/>
+          </a:xfrm>
+          <a:prstGeom prst="rect">
+            <a:avLst/>
+          </a:prstGeom>
+          <a:noFill/>
+          <a:ln/>
+        </p:spPr>
+        <p:txBody>
+          <a:bodyPr wrap="square" lIns="0" tIns="0" rIns="0" bIns="0" rtlCol="0" anchor="ctr"/>
+          <a:lstStyle/>
+          <a:p>
+            <a:pPr marL="0" indent="0">
+              <a:buNone/>
+            </a:pPr>
+            <a:r>
+              <a:rPr lang="en-US" sz="1050" dirty="0">
+                <a:solidFill>
+                  <a:srgbClr val="64748B"/>
+                </a:solidFill>
+              </a:rPr>
+              <a:t>Not an official U.S. government publication. Independent technical analysis; not reviewed or endorsed by any federal agency.</a:t>
+            </a:r>
+            <a:endParaRPr lang="en-US" sz="1050" dirty="0"/>
+          </a:p>
+        </p:txBody>
+      </p:sp>
+      <p:sp>
+        <p:nvSpPr>
+          <p:cNvPr id="6" name="Agenda line"/>
           <p:cNvSpPr txBox="1"/>
           <p:nvPr/>
         </p:nvSpPr>
@@ -2118,7 +2198,7 @@
       </p:sp>
       <p:sp>
         <p:nvSpPr>
-          <p:cNvPr id="5" name="Series line"/>
+          <p:cNvPr id="7" name="Series line"/>
           <p:cNvSpPr txBox="1"/>
           <p:nvPr/>
         </p:nvSpPr>
@@ -2146,7 +2226,7 @@
                   <a:srgbClr val="1F2A44"/>
                 </a:solidFill>
               </a:rPr>
-              <a:t>Modernization Workbook</a:t>
+              <a:t>Federal Modernization Workbook</a:t>
             </a:r>
             <a:endParaRPr lang="en-US" sz="1600" dirty="0"/>
           </a:p>
@@ -2168,11 +2248,11 @@
       </p:sp>
       <p:pic>
         <p:nvPicPr>
-          <p:cNvPr id="6" name="Narration">
+          <p:cNvPr id="8" name="Narration" descr="Narration for this slide; captions available">
             <a:hlinkClick r:id="" action="ppaction://media"/>
             <a:extLst>
               <a:ext uri="{FF2B5EF4-FFF2-40B4-BE49-F238E27FC236}">
-                <a16:creationId xmlns:a16="http://schemas.microsoft.com/office/drawing/2014/main" id="{8F13AE23-2601-7E56-F9D9-5FBD72B2028B}"/>
+                <a16:creationId xmlns:a16="http://schemas.microsoft.com/office/drawing/2014/main" id="{7FE0509C-4C33-1C82-E704-D45EC6E383A0}"/>
               </a:ext>
             </a:extLst>
           </p:cNvPr>
@@ -2183,7 +2263,17 @@
             <a:audioFile r:link="rId2"/>
             <p:extLst>
               <p:ext uri="{DAA4B4D4-6D71-4841-9C94-3DE7FCFB9230}">
-                <p14:media xmlns:p14="http://schemas.microsoft.com/office/powerpoint/2010/main" r:embed="rId1"/>
+                <p14:media xmlns:p14="http://schemas.microsoft.com/office/powerpoint/2010/main" r:embed="rId1">
+                  <p14:extLst>
+                    <p:ext uri="{3AFAAA56-56D3-431D-BCD4-E75A35582382}">
+                      <p173:tracksInfo xmlns:p173="http://schemas.microsoft.com/office/powerpoint/2017/3/main" displayLoc="slide">
+                        <p173:trackLst>
+                          <p173:track id="{13E783A0-EAAA-44E9-A20A-5274C36BF11B}" label="English (captions)" lang="en-US" r:embed="rId6"/>
+                        </p173:trackLst>
+                      </p173:tracksInfo>
+                    </p:ext>
+                  </p14:extLst>
+                </p14:media>
               </p:ext>
             </p:extLst>
           </p:nvPr>
@@ -2211,10 +2301,10 @@
   </p:clrMapOvr>
   <mc:AlternateContent xmlns:mc="http://schemas.openxmlformats.org/markup-compatibility/2006">
     <mc:Choice xmlns:p14="http://schemas.microsoft.com/office/powerpoint/2010/main" Requires="p14">
-      <p:transition spd="slow" p14:dur="2000" advTm="30640"/>
+      <p:transition spd="slow" p14:dur="2000" advTm="31020"/>
     </mc:Choice>
     <mc:Fallback>
-      <p:transition spd="slow" advTm="30640"/>
+      <p:transition spd="slow" advTm="31020"/>
     </mc:Fallback>
   </mc:AlternateContent>
   <p:timing>
@@ -2248,9 +2338,9 @@
                                   <p:childTnLst>
                                     <p:cmd type="call" cmd="playFrom(0.0)">
                                       <p:cBhvr>
-                                        <p:cTn id="6" dur="29640" fill="hold"/>
+                                        <p:cTn id="6" dur="30024" fill="hold"/>
                                         <p:tgtEl>
-                                          <p:spTgt spid="6"/>
+                                          <p:spTgt spid="8"/>
                                         </p:tgtEl>
                                       </p:cBhvr>
                                     </p:cmd>
@@ -2350,7 +2440,13 @@
       </p:sp>
       <p:sp>
         <p:nvSpPr>
-          <p:cNvPr id="3" name="Tag How"/>
+          <p:cNvPr id="3" name="Tag How">
+            <a:extLst>
+              <a:ext uri="{C183D7F6-B498-43B3-948B-1728B52AA6E4}">
+                <adec:decorative xmlns:adec="http://schemas.microsoft.com/office/drawing/2017/decorative" val="1"/>
+              </a:ext>
+            </a:extLst>
+          </p:cNvPr>
           <p:cNvSpPr/>
           <p:nvPr/>
         </p:nvSpPr>
@@ -2413,7 +2509,13 @@
       </p:sp>
       <p:sp>
         <p:nvSpPr>
-          <p:cNvPr id="5" name="Phase 1"/>
+          <p:cNvPr id="5" name="Phase 1">
+            <a:extLst>
+              <a:ext uri="{C183D7F6-B498-43B3-948B-1728B52AA6E4}">
+                <adec:decorative xmlns:adec="http://schemas.microsoft.com/office/drawing/2017/decorative" val="1"/>
+              </a:ext>
+            </a:extLst>
+          </p:cNvPr>
           <p:cNvSpPr/>
           <p:nvPr/>
         </p:nvSpPr>
@@ -2491,7 +2593,13 @@
       </p:sp>
       <p:sp>
         <p:nvSpPr>
-          <p:cNvPr id="7" name="Phase 2"/>
+          <p:cNvPr id="7" name="Phase 2">
+            <a:extLst>
+              <a:ext uri="{C183D7F6-B498-43B3-948B-1728B52AA6E4}">
+                <adec:decorative xmlns:adec="http://schemas.microsoft.com/office/drawing/2017/decorative" val="1"/>
+              </a:ext>
+            </a:extLst>
+          </p:cNvPr>
           <p:cNvSpPr/>
           <p:nvPr/>
         </p:nvSpPr>
@@ -2569,7 +2677,13 @@
       </p:sp>
       <p:sp>
         <p:nvSpPr>
-          <p:cNvPr id="9" name="Phase 3"/>
+          <p:cNvPr id="9" name="Phase 3">
+            <a:extLst>
+              <a:ext uri="{C183D7F6-B498-43B3-948B-1728B52AA6E4}">
+                <adec:decorative xmlns:adec="http://schemas.microsoft.com/office/drawing/2017/decorative" val="1"/>
+              </a:ext>
+            </a:extLst>
+          </p:cNvPr>
           <p:cNvSpPr/>
           <p:nvPr/>
         </p:nvSpPr>
@@ -2647,7 +2761,13 @@
       </p:sp>
       <p:sp>
         <p:nvSpPr>
-          <p:cNvPr id="11" name="Phase 4"/>
+          <p:cNvPr id="11" name="Phase 4">
+            <a:extLst>
+              <a:ext uri="{C183D7F6-B498-43B3-948B-1728B52AA6E4}">
+                <adec:decorative xmlns:adec="http://schemas.microsoft.com/office/drawing/2017/decorative" val="1"/>
+              </a:ext>
+            </a:extLst>
+          </p:cNvPr>
           <p:cNvSpPr/>
           <p:nvPr/>
         </p:nvSpPr>
@@ -2725,7 +2845,13 @@
       </p:sp>
       <p:sp>
         <p:nvSpPr>
-          <p:cNvPr id="13" name="Phase 5"/>
+          <p:cNvPr id="13" name="Phase 5">
+            <a:extLst>
+              <a:ext uri="{C183D7F6-B498-43B3-948B-1728B52AA6E4}">
+                <adec:decorative xmlns:adec="http://schemas.microsoft.com/office/drawing/2017/decorative" val="1"/>
+              </a:ext>
+            </a:extLst>
+          </p:cNvPr>
           <p:cNvSpPr/>
           <p:nvPr/>
         </p:nvSpPr>
@@ -2803,7 +2929,13 @@
       </p:sp>
       <p:sp>
         <p:nvSpPr>
-          <p:cNvPr id="15" name="Bundle box"/>
+          <p:cNvPr id="15" name="Bundle box">
+            <a:extLst>
+              <a:ext uri="{C183D7F6-B498-43B3-948B-1728B52AA6E4}">
+                <adec:decorative xmlns:adec="http://schemas.microsoft.com/office/drawing/2017/decorative" val="1"/>
+              </a:ext>
+            </a:extLst>
+          </p:cNvPr>
           <p:cNvSpPr/>
           <p:nvPr/>
         </p:nvSpPr>
@@ -2837,7 +2969,13 @@
       </p:sp>
       <p:sp>
         <p:nvSpPr>
-          <p:cNvPr id="16" name="Icon FaFileShield"/>
+          <p:cNvPr id="16" name="Icon FaFileShield">
+            <a:extLst>
+              <a:ext uri="{C183D7F6-B498-43B3-948B-1728B52AA6E4}">
+                <adec:decorative xmlns:adec="http://schemas.microsoft.com/office/drawing/2017/decorative" val="1"/>
+              </a:ext>
+            </a:extLst>
+          </p:cNvPr>
           <p:cNvSpPr/>
           <p:nvPr/>
         </p:nvSpPr>
@@ -2862,7 +3000,13 @@
       </p:sp>
       <p:pic>
         <p:nvPicPr>
-          <p:cNvPr id="17" name="Image 0" descr="C:\Users\whale\git\mwb-b02\presentations\_build\icons\FaFileShield.png"/>
+          <p:cNvPr id="17" name="Image 0">
+            <a:extLst>
+              <a:ext uri="{C183D7F6-B498-43B3-948B-1728B52AA6E4}">
+                <adec:decorative xmlns:adec="http://schemas.microsoft.com/office/drawing/2017/decorative" val="1"/>
+              </a:ext>
+            </a:extLst>
+          </p:cNvPr>
           <p:cNvPicPr>
             <a:picLocks noChangeAspect="1"/>
           </p:cNvPicPr>
@@ -3033,7 +3177,13 @@
       </p:sp>
       <p:sp>
         <p:nvSpPr>
-          <p:cNvPr id="20" name="Framing"/>
+          <p:cNvPr id="20" name="Framing">
+            <a:extLst>
+              <a:ext uri="{C183D7F6-B498-43B3-948B-1728B52AA6E4}">
+                <adec:decorative xmlns:adec="http://schemas.microsoft.com/office/drawing/2017/decorative" val="1"/>
+              </a:ext>
+            </a:extLst>
+          </p:cNvPr>
           <p:cNvSpPr/>
           <p:nvPr/>
         </p:nvSpPr>
@@ -3067,7 +3217,13 @@
       </p:sp>
       <p:sp>
         <p:nvSpPr>
-          <p:cNvPr id="21" name="Icon FaBuilding"/>
+          <p:cNvPr id="21" name="Icon FaBuilding">
+            <a:extLst>
+              <a:ext uri="{C183D7F6-B498-43B3-948B-1728B52AA6E4}">
+                <adec:decorative xmlns:adec="http://schemas.microsoft.com/office/drawing/2017/decorative" val="1"/>
+              </a:ext>
+            </a:extLst>
+          </p:cNvPr>
           <p:cNvSpPr/>
           <p:nvPr/>
         </p:nvSpPr>
@@ -3092,7 +3248,13 @@
       </p:sp>
       <p:pic>
         <p:nvPicPr>
-          <p:cNvPr id="22" name="Image 1" descr="C:\Users\whale\git\mwb-b02\presentations\_build\icons\FaBuilding.png"/>
+          <p:cNvPr id="22" name="Image 1">
+            <a:extLst>
+              <a:ext uri="{C183D7F6-B498-43B3-948B-1728B52AA6E4}">
+                <adec:decorative xmlns:adec="http://schemas.microsoft.com/office/drawing/2017/decorative" val="1"/>
+              </a:ext>
+            </a:extLst>
+          </p:cNvPr>
           <p:cNvPicPr>
             <a:picLocks noChangeAspect="1"/>
           </p:cNvPicPr>
@@ -3241,11 +3403,11 @@
       </p:sp>
       <p:pic>
         <p:nvPicPr>
-          <p:cNvPr id="26" name="Narration">
+          <p:cNvPr id="26" name="Narration" descr="Narration for this slide; captions available">
             <a:hlinkClick r:id="" action="ppaction://media"/>
             <a:extLst>
               <a:ext uri="{FF2B5EF4-FFF2-40B4-BE49-F238E27FC236}">
-                <a16:creationId xmlns:a16="http://schemas.microsoft.com/office/drawing/2014/main" id="{AF28C65E-7D0B-C08D-CC24-D455345228C3}"/>
+                <a16:creationId xmlns:a16="http://schemas.microsoft.com/office/drawing/2014/main" id="{D17F26EF-8B81-B4D2-2717-822839907F5F}"/>
               </a:ext>
             </a:extLst>
           </p:cNvPr>
@@ -3256,7 +3418,17 @@
             <a:audioFile r:link="rId2"/>
             <p:extLst>
               <p:ext uri="{DAA4B4D4-6D71-4841-9C94-3DE7FCFB9230}">
-                <p14:media xmlns:p14="http://schemas.microsoft.com/office/powerpoint/2010/main" r:embed="rId1"/>
+                <p14:media xmlns:p14="http://schemas.microsoft.com/office/powerpoint/2010/main" r:embed="rId1">
+                  <p14:extLst>
+                    <p:ext uri="{3AFAAA56-56D3-431D-BCD4-E75A35582382}">
+                      <p173:tracksInfo xmlns:p173="http://schemas.microsoft.com/office/powerpoint/2017/3/main" displayLoc="slide">
+                        <p173:trackLst>
+                          <p173:track id="{3041292E-F641-4230-A558-62968ADA2093}" label="English (captions)" lang="en-US" r:embed="rId8"/>
+                        </p173:trackLst>
+                      </p173:tracksInfo>
+                    </p:ext>
+                  </p14:extLst>
+                </p14:media>
               </p:ext>
             </p:extLst>
           </p:nvPr>
@@ -3423,7 +3595,13 @@
       </p:sp>
       <p:sp>
         <p:nvSpPr>
-          <p:cNvPr id="3" name="Tag How"/>
+          <p:cNvPr id="3" name="Tag How">
+            <a:extLst>
+              <a:ext uri="{C183D7F6-B498-43B3-948B-1728B52AA6E4}">
+                <adec:decorative xmlns:adec="http://schemas.microsoft.com/office/drawing/2017/decorative" val="1"/>
+              </a:ext>
+            </a:extLst>
+          </p:cNvPr>
           <p:cNvSpPr/>
           <p:nvPr/>
         </p:nvSpPr>
@@ -3486,7 +3664,13 @@
       </p:sp>
       <p:sp>
         <p:nvSpPr>
-          <p:cNvPr id="5" name="Ask 1"/>
+          <p:cNvPr id="5" name="Ask 1">
+            <a:extLst>
+              <a:ext uri="{C183D7F6-B498-43B3-948B-1728B52AA6E4}">
+                <adec:decorative xmlns:adec="http://schemas.microsoft.com/office/drawing/2017/decorative" val="1"/>
+              </a:ext>
+            </a:extLst>
+          </p:cNvPr>
           <p:cNvSpPr/>
           <p:nvPr/>
         </p:nvSpPr>
@@ -3520,7 +3704,13 @@
       </p:sp>
       <p:sp>
         <p:nvSpPr>
-          <p:cNvPr id="6" name="Icon FaUserCheck"/>
+          <p:cNvPr id="6" name="Icon FaUserCheck">
+            <a:extLst>
+              <a:ext uri="{C183D7F6-B498-43B3-948B-1728B52AA6E4}">
+                <adec:decorative xmlns:adec="http://schemas.microsoft.com/office/drawing/2017/decorative" val="1"/>
+              </a:ext>
+            </a:extLst>
+          </p:cNvPr>
           <p:cNvSpPr/>
           <p:nvPr/>
         </p:nvSpPr>
@@ -3545,7 +3735,13 @@
       </p:sp>
       <p:pic>
         <p:nvPicPr>
-          <p:cNvPr id="7" name="Image 0" descr="C:\Users\whale\git\mwb-b02\presentations\_build\icons\FaUserCheck.png"/>
+          <p:cNvPr id="7" name="Image 0">
+            <a:extLst>
+              <a:ext uri="{C183D7F6-B498-43B3-948B-1728B52AA6E4}">
+                <adec:decorative xmlns:adec="http://schemas.microsoft.com/office/drawing/2017/decorative" val="1"/>
+              </a:ext>
+            </a:extLst>
+          </p:cNvPr>
           <p:cNvPicPr>
             <a:picLocks noChangeAspect="1"/>
           </p:cNvPicPr>
@@ -3622,7 +3818,13 @@
       </p:sp>
       <p:sp>
         <p:nvSpPr>
-          <p:cNvPr id="9" name="Ask 2"/>
+          <p:cNvPr id="9" name="Ask 2">
+            <a:extLst>
+              <a:ext uri="{C183D7F6-B498-43B3-948B-1728B52AA6E4}">
+                <adec:decorative xmlns:adec="http://schemas.microsoft.com/office/drawing/2017/decorative" val="1"/>
+              </a:ext>
+            </a:extLst>
+          </p:cNvPr>
           <p:cNvSpPr/>
           <p:nvPr/>
         </p:nvSpPr>
@@ -3656,7 +3858,13 @@
       </p:sp>
       <p:sp>
         <p:nvSpPr>
-          <p:cNvPr id="10" name="Icon FaListCheck"/>
+          <p:cNvPr id="10" name="Icon FaListCheck">
+            <a:extLst>
+              <a:ext uri="{C183D7F6-B498-43B3-948B-1728B52AA6E4}">
+                <adec:decorative xmlns:adec="http://schemas.microsoft.com/office/drawing/2017/decorative" val="1"/>
+              </a:ext>
+            </a:extLst>
+          </p:cNvPr>
           <p:cNvSpPr/>
           <p:nvPr/>
         </p:nvSpPr>
@@ -3681,7 +3889,13 @@
       </p:sp>
       <p:pic>
         <p:nvPicPr>
-          <p:cNvPr id="11" name="Image 1" descr="C:\Users\whale\git\mwb-b02\presentations\_build\icons\FaListCheck.png"/>
+          <p:cNvPr id="11" name="Image 1">
+            <a:extLst>
+              <a:ext uri="{C183D7F6-B498-43B3-948B-1728B52AA6E4}">
+                <adec:decorative xmlns:adec="http://schemas.microsoft.com/office/drawing/2017/decorative" val="1"/>
+              </a:ext>
+            </a:extLst>
+          </p:cNvPr>
           <p:cNvPicPr>
             <a:picLocks noChangeAspect="1"/>
           </p:cNvPicPr>
@@ -3758,7 +3972,13 @@
       </p:sp>
       <p:sp>
         <p:nvSpPr>
-          <p:cNvPr id="13" name="Ask 3"/>
+          <p:cNvPr id="13" name="Ask 3">
+            <a:extLst>
+              <a:ext uri="{C183D7F6-B498-43B3-948B-1728B52AA6E4}">
+                <adec:decorative xmlns:adec="http://schemas.microsoft.com/office/drawing/2017/decorative" val="1"/>
+              </a:ext>
+            </a:extLst>
+          </p:cNvPr>
           <p:cNvSpPr/>
           <p:nvPr/>
         </p:nvSpPr>
@@ -3792,7 +4012,13 @@
       </p:sp>
       <p:sp>
         <p:nvSpPr>
-          <p:cNvPr id="14" name="Icon FaUserClock"/>
+          <p:cNvPr id="14" name="Icon FaUserClock">
+            <a:extLst>
+              <a:ext uri="{C183D7F6-B498-43B3-948B-1728B52AA6E4}">
+                <adec:decorative xmlns:adec="http://schemas.microsoft.com/office/drawing/2017/decorative" val="1"/>
+              </a:ext>
+            </a:extLst>
+          </p:cNvPr>
           <p:cNvSpPr/>
           <p:nvPr/>
         </p:nvSpPr>
@@ -3817,7 +4043,13 @@
       </p:sp>
       <p:pic>
         <p:nvPicPr>
-          <p:cNvPr id="15" name="Image 2" descr="C:\Users\whale\git\mwb-b02\presentations\_build\icons\FaUserClock.png"/>
+          <p:cNvPr id="15" name="Image 2">
+            <a:extLst>
+              <a:ext uri="{C183D7F6-B498-43B3-948B-1728B52AA6E4}">
+                <adec:decorative xmlns:adec="http://schemas.microsoft.com/office/drawing/2017/decorative" val="1"/>
+              </a:ext>
+            </a:extLst>
+          </p:cNvPr>
           <p:cNvPicPr>
             <a:picLocks noChangeAspect="1"/>
           </p:cNvPicPr>
@@ -3894,7 +4126,13 @@
       </p:sp>
       <p:sp>
         <p:nvSpPr>
-          <p:cNvPr id="17" name="Ask 4"/>
+          <p:cNvPr id="17" name="Ask 4">
+            <a:extLst>
+              <a:ext uri="{C183D7F6-B498-43B3-948B-1728B52AA6E4}">
+                <adec:decorative xmlns:adec="http://schemas.microsoft.com/office/drawing/2017/decorative" val="1"/>
+              </a:ext>
+            </a:extLst>
+          </p:cNvPr>
           <p:cNvSpPr/>
           <p:nvPr/>
         </p:nvSpPr>
@@ -3928,7 +4166,13 @@
       </p:sp>
       <p:sp>
         <p:nvSpPr>
-          <p:cNvPr id="18" name="Icon FaFileShield"/>
+          <p:cNvPr id="18" name="Icon FaFileShield">
+            <a:extLst>
+              <a:ext uri="{C183D7F6-B498-43B3-948B-1728B52AA6E4}">
+                <adec:decorative xmlns:adec="http://schemas.microsoft.com/office/drawing/2017/decorative" val="1"/>
+              </a:ext>
+            </a:extLst>
+          </p:cNvPr>
           <p:cNvSpPr/>
           <p:nvPr/>
         </p:nvSpPr>
@@ -3953,7 +4197,13 @@
       </p:sp>
       <p:pic>
         <p:nvPicPr>
-          <p:cNvPr id="19" name="Image 3" descr="C:\Users\whale\git\mwb-b02\presentations\_build\icons\FaFileShield.png"/>
+          <p:cNvPr id="19" name="Image 3">
+            <a:extLst>
+              <a:ext uri="{C183D7F6-B498-43B3-948B-1728B52AA6E4}">
+                <adec:decorative xmlns:adec="http://schemas.microsoft.com/office/drawing/2017/decorative" val="1"/>
+              </a:ext>
+            </a:extLst>
+          </p:cNvPr>
           <p:cNvPicPr>
             <a:picLocks noChangeAspect="1"/>
           </p:cNvPicPr>
@@ -4030,7 +4280,13 @@
       </p:sp>
       <p:sp>
         <p:nvSpPr>
-          <p:cNvPr id="21" name="Close"/>
+          <p:cNvPr id="21" name="Close">
+            <a:extLst>
+              <a:ext uri="{C183D7F6-B498-43B3-948B-1728B52AA6E4}">
+                <adec:decorative xmlns:adec="http://schemas.microsoft.com/office/drawing/2017/decorative" val="1"/>
+              </a:ext>
+            </a:extLst>
+          </p:cNvPr>
           <p:cNvSpPr/>
           <p:nvPr/>
         </p:nvSpPr>
@@ -4064,7 +4320,13 @@
       </p:sp>
       <p:sp>
         <p:nvSpPr>
-          <p:cNvPr id="22" name="Icon FaBook"/>
+          <p:cNvPr id="22" name="Icon FaBook">
+            <a:extLst>
+              <a:ext uri="{C183D7F6-B498-43B3-948B-1728B52AA6E4}">
+                <adec:decorative xmlns:adec="http://schemas.microsoft.com/office/drawing/2017/decorative" val="1"/>
+              </a:ext>
+            </a:extLst>
+          </p:cNvPr>
           <p:cNvSpPr/>
           <p:nvPr/>
         </p:nvSpPr>
@@ -4089,7 +4351,13 @@
       </p:sp>
       <p:pic>
         <p:nvPicPr>
-          <p:cNvPr id="23" name="Image 4" descr="C:\Users\whale\git\mwb-b02\presentations\_build\icons\FaBook.png"/>
+          <p:cNvPr id="23" name="Image 4">
+            <a:extLst>
+              <a:ext uri="{C183D7F6-B498-43B3-948B-1728B52AA6E4}">
+                <adec:decorative xmlns:adec="http://schemas.microsoft.com/office/drawing/2017/decorative" val="1"/>
+              </a:ext>
+            </a:extLst>
+          </p:cNvPr>
           <p:cNvPicPr>
             <a:picLocks noChangeAspect="1"/>
           </p:cNvPicPr>
@@ -4202,11 +4470,11 @@
       </p:sp>
       <p:pic>
         <p:nvPicPr>
-          <p:cNvPr id="26" name="Narration">
+          <p:cNvPr id="26" name="Narration" descr="Narration for this slide; captions available">
             <a:hlinkClick r:id="" action="ppaction://media"/>
             <a:extLst>
               <a:ext uri="{FF2B5EF4-FFF2-40B4-BE49-F238E27FC236}">
-                <a16:creationId xmlns:a16="http://schemas.microsoft.com/office/drawing/2014/main" id="{C87575CA-9614-4CA2-A999-D9674D81B74A}"/>
+                <a16:creationId xmlns:a16="http://schemas.microsoft.com/office/drawing/2014/main" id="{5D0C1AEA-1085-5020-75A1-BBF2D497C3F6}"/>
               </a:ext>
             </a:extLst>
           </p:cNvPr>
@@ -4217,7 +4485,17 @@
             <a:audioFile r:link="rId2"/>
             <p:extLst>
               <p:ext uri="{DAA4B4D4-6D71-4841-9C94-3DE7FCFB9230}">
-                <p14:media xmlns:p14="http://schemas.microsoft.com/office/powerpoint/2010/main" r:embed="rId1"/>
+                <p14:media xmlns:p14="http://schemas.microsoft.com/office/powerpoint/2010/main" r:embed="rId1">
+                  <p14:extLst>
+                    <p:ext uri="{3AFAAA56-56D3-431D-BCD4-E75A35582382}">
+                      <p173:tracksInfo xmlns:p173="http://schemas.microsoft.com/office/powerpoint/2017/3/main" displayLoc="slide">
+                        <p173:trackLst>
+                          <p173:track id="{5737E283-3AB7-47C4-B7EA-CD72186C2FA0}" label="English (captions)" lang="en-US" r:embed="rId11"/>
+                        </p173:trackLst>
+                      </p173:tracksInfo>
+                    </p:ext>
+                  </p14:extLst>
+                </p14:media>
               </p:ext>
             </p:extLst>
           </p:nvPr>
@@ -4384,7 +4662,13 @@
       </p:sp>
       <p:sp>
         <p:nvSpPr>
-          <p:cNvPr id="3" name="Tag Why"/>
+          <p:cNvPr id="3" name="Tag Why">
+            <a:extLst>
+              <a:ext uri="{C183D7F6-B498-43B3-948B-1728B52AA6E4}">
+                <adec:decorative xmlns:adec="http://schemas.microsoft.com/office/drawing/2017/decorative" val="1"/>
+              </a:ext>
+            </a:extLst>
+          </p:cNvPr>
           <p:cNvSpPr/>
           <p:nvPr/>
         </p:nvSpPr>
@@ -4483,7 +4767,13 @@
       </p:sp>
       <p:sp>
         <p:nvSpPr>
-          <p:cNvPr id="6" name="Icon FaLandmark"/>
+          <p:cNvPr id="6" name="Icon FaLandmark">
+            <a:extLst>
+              <a:ext uri="{C183D7F6-B498-43B3-948B-1728B52AA6E4}">
+                <adec:decorative xmlns:adec="http://schemas.microsoft.com/office/drawing/2017/decorative" val="1"/>
+              </a:ext>
+            </a:extLst>
+          </p:cNvPr>
           <p:cNvSpPr/>
           <p:nvPr/>
         </p:nvSpPr>
@@ -4508,7 +4798,13 @@
       </p:sp>
       <p:pic>
         <p:nvPicPr>
-          <p:cNvPr id="7" name="Image 0" descr="C:\Users\whale\git\mwb-b02\presentations\_build\icons\FaLandmark.png"/>
+          <p:cNvPr id="7" name="Image 0">
+            <a:extLst>
+              <a:ext uri="{C183D7F6-B498-43B3-948B-1728B52AA6E4}">
+                <adec:decorative xmlns:adec="http://schemas.microsoft.com/office/drawing/2017/decorative" val="1"/>
+              </a:ext>
+            </a:extLst>
+          </p:cNvPr>
           <p:cNvPicPr>
             <a:picLocks noChangeAspect="1"/>
           </p:cNvPicPr>
@@ -4582,7 +4878,13 @@
       </p:sp>
       <p:sp>
         <p:nvSpPr>
-          <p:cNvPr id="9" name="Icon FaBook"/>
+          <p:cNvPr id="9" name="Icon FaBook">
+            <a:extLst>
+              <a:ext uri="{C183D7F6-B498-43B3-948B-1728B52AA6E4}">
+                <adec:decorative xmlns:adec="http://schemas.microsoft.com/office/drawing/2017/decorative" val="1"/>
+              </a:ext>
+            </a:extLst>
+          </p:cNvPr>
           <p:cNvSpPr/>
           <p:nvPr/>
         </p:nvSpPr>
@@ -4607,7 +4909,13 @@
       </p:sp>
       <p:pic>
         <p:nvPicPr>
-          <p:cNvPr id="10" name="Image 1" descr="C:\Users\whale\git\mwb-b02\presentations\_build\icons\FaBook.png"/>
+          <p:cNvPr id="10" name="Image 1">
+            <a:extLst>
+              <a:ext uri="{C183D7F6-B498-43B3-948B-1728B52AA6E4}">
+                <adec:decorative xmlns:adec="http://schemas.microsoft.com/office/drawing/2017/decorative" val="1"/>
+              </a:ext>
+            </a:extLst>
+          </p:cNvPr>
           <p:cNvPicPr>
             <a:picLocks noChangeAspect="1"/>
           </p:cNvPicPr>
@@ -4681,7 +4989,13 @@
       </p:sp>
       <p:sp>
         <p:nvSpPr>
-          <p:cNvPr id="12" name="Icon FaSitemap"/>
+          <p:cNvPr id="12" name="Icon FaSitemap">
+            <a:extLst>
+              <a:ext uri="{C183D7F6-B498-43B3-948B-1728B52AA6E4}">
+                <adec:decorative xmlns:adec="http://schemas.microsoft.com/office/drawing/2017/decorative" val="1"/>
+              </a:ext>
+            </a:extLst>
+          </p:cNvPr>
           <p:cNvSpPr/>
           <p:nvPr/>
         </p:nvSpPr>
@@ -4706,7 +5020,13 @@
       </p:sp>
       <p:pic>
         <p:nvPicPr>
-          <p:cNvPr id="13" name="Image 2" descr="C:\Users\whale\git\mwb-b02\presentations\_build\icons\FaSitemap.png"/>
+          <p:cNvPr id="13" name="Image 2">
+            <a:extLst>
+              <a:ext uri="{C183D7F6-B498-43B3-948B-1728B52AA6E4}">
+                <adec:decorative xmlns:adec="http://schemas.microsoft.com/office/drawing/2017/decorative" val="1"/>
+              </a:ext>
+            </a:extLst>
+          </p:cNvPr>
           <p:cNvPicPr>
             <a:picLocks noChangeAspect="1"/>
           </p:cNvPicPr>
@@ -4780,7 +5100,13 @@
       </p:sp>
       <p:sp>
         <p:nvSpPr>
-          <p:cNvPr id="15" name="Consequence box"/>
+          <p:cNvPr id="15" name="Consequence box">
+            <a:extLst>
+              <a:ext uri="{C183D7F6-B498-43B3-948B-1728B52AA6E4}">
+                <adec:decorative xmlns:adec="http://schemas.microsoft.com/office/drawing/2017/decorative" val="1"/>
+              </a:ext>
+            </a:extLst>
+          </p:cNvPr>
           <p:cNvSpPr/>
           <p:nvPr/>
         </p:nvSpPr>
@@ -4814,7 +5140,13 @@
       </p:sp>
       <p:sp>
         <p:nvSpPr>
-          <p:cNvPr id="16" name="Icon FaIdCard"/>
+          <p:cNvPr id="16" name="Icon FaIdCard">
+            <a:extLst>
+              <a:ext uri="{C183D7F6-B498-43B3-948B-1728B52AA6E4}">
+                <adec:decorative xmlns:adec="http://schemas.microsoft.com/office/drawing/2017/decorative" val="1"/>
+              </a:ext>
+            </a:extLst>
+          </p:cNvPr>
           <p:cNvSpPr/>
           <p:nvPr/>
         </p:nvSpPr>
@@ -4839,7 +5171,13 @@
       </p:sp>
       <p:pic>
         <p:nvPicPr>
-          <p:cNvPr id="17" name="Image 3" descr="C:\Users\whale\git\mwb-b02\presentations\_build\icons\FaIdCard.png"/>
+          <p:cNvPr id="17" name="Image 3">
+            <a:extLst>
+              <a:ext uri="{C183D7F6-B498-43B3-948B-1728B52AA6E4}">
+                <adec:decorative xmlns:adec="http://schemas.microsoft.com/office/drawing/2017/decorative" val="1"/>
+              </a:ext>
+            </a:extLst>
+          </p:cNvPr>
           <p:cNvPicPr>
             <a:picLocks noChangeAspect="1"/>
           </p:cNvPicPr>
@@ -5028,7 +5366,13 @@
       </p:sp>
       <p:sp>
         <p:nvSpPr>
-          <p:cNvPr id="21" name="Not an upgrade"/>
+          <p:cNvPr id="21" name="Not an upgrade">
+            <a:extLst>
+              <a:ext uri="{C183D7F6-B498-43B3-948B-1728B52AA6E4}">
+                <adec:decorative xmlns:adec="http://schemas.microsoft.com/office/drawing/2017/decorative" val="1"/>
+              </a:ext>
+            </a:extLst>
+          </p:cNvPr>
           <p:cNvSpPr/>
           <p:nvPr/>
         </p:nvSpPr>
@@ -5062,7 +5406,13 @@
       </p:sp>
       <p:sp>
         <p:nvSpPr>
-          <p:cNvPr id="22" name="Icon FaTriangleExclamation"/>
+          <p:cNvPr id="22" name="Icon FaTriangleExclamation">
+            <a:extLst>
+              <a:ext uri="{C183D7F6-B498-43B3-948B-1728B52AA6E4}">
+                <adec:decorative xmlns:adec="http://schemas.microsoft.com/office/drawing/2017/decorative" val="1"/>
+              </a:ext>
+            </a:extLst>
+          </p:cNvPr>
           <p:cNvSpPr/>
           <p:nvPr/>
         </p:nvSpPr>
@@ -5087,7 +5437,13 @@
       </p:sp>
       <p:pic>
         <p:nvPicPr>
-          <p:cNvPr id="23" name="Image 4" descr="C:\Users\whale\git\mwb-b02\presentations\_build\icons\FaTriangleExclamation.png"/>
+          <p:cNvPr id="23" name="Image 4">
+            <a:extLst>
+              <a:ext uri="{C183D7F6-B498-43B3-948B-1728B52AA6E4}">
+                <adec:decorative xmlns:adec="http://schemas.microsoft.com/office/drawing/2017/decorative" val="1"/>
+              </a:ext>
+            </a:extLst>
+          </p:cNvPr>
           <p:cNvPicPr>
             <a:picLocks noChangeAspect="1"/>
           </p:cNvPicPr>
@@ -5236,11 +5592,11 @@
       </p:sp>
       <p:pic>
         <p:nvPicPr>
-          <p:cNvPr id="27" name="Narration">
+          <p:cNvPr id="27" name="Narration" descr="Narration for this slide; captions available">
             <a:hlinkClick r:id="" action="ppaction://media"/>
             <a:extLst>
               <a:ext uri="{FF2B5EF4-FFF2-40B4-BE49-F238E27FC236}">
-                <a16:creationId xmlns:a16="http://schemas.microsoft.com/office/drawing/2014/main" id="{2BBF1DC9-9887-BC34-4BA4-9EFD1E2EE450}"/>
+                <a16:creationId xmlns:a16="http://schemas.microsoft.com/office/drawing/2014/main" id="{89A82CC7-7D64-0ACB-E99A-259EFC665200}"/>
               </a:ext>
             </a:extLst>
           </p:cNvPr>
@@ -5251,7 +5607,17 @@
             <a:audioFile r:link="rId2"/>
             <p:extLst>
               <p:ext uri="{DAA4B4D4-6D71-4841-9C94-3DE7FCFB9230}">
-                <p14:media xmlns:p14="http://schemas.microsoft.com/office/powerpoint/2010/main" r:embed="rId1"/>
+                <p14:media xmlns:p14="http://schemas.microsoft.com/office/powerpoint/2010/main" r:embed="rId1">
+                  <p14:extLst>
+                    <p:ext uri="{3AFAAA56-56D3-431D-BCD4-E75A35582382}">
+                      <p173:tracksInfo xmlns:p173="http://schemas.microsoft.com/office/powerpoint/2017/3/main" displayLoc="slide">
+                        <p173:trackLst>
+                          <p173:track id="{A7F21003-1F1B-4BEA-86EB-1C25FD729A2D}" label="English (captions)" lang="en-US" r:embed="rId11"/>
+                        </p173:trackLst>
+                      </p173:tracksInfo>
+                    </p:ext>
+                  </p14:extLst>
+                </p14:media>
               </p:ext>
             </p:extLst>
           </p:nvPr>
@@ -5418,7 +5784,13 @@
       </p:sp>
       <p:sp>
         <p:nvSpPr>
-          <p:cNvPr id="3" name="Tag Why"/>
+          <p:cNvPr id="3" name="Tag Why">
+            <a:extLst>
+              <a:ext uri="{C183D7F6-B498-43B3-948B-1728B52AA6E4}">
+                <adec:decorative xmlns:adec="http://schemas.microsoft.com/office/drawing/2017/decorative" val="1"/>
+              </a:ext>
+            </a:extLst>
+          </p:cNvPr>
           <p:cNvSpPr/>
           <p:nvPr/>
         </p:nvSpPr>
@@ -5481,7 +5853,13 @@
       </p:sp>
       <p:sp>
         <p:nvSpPr>
-          <p:cNvPr id="5" name="Date 1"/>
+          <p:cNvPr id="5" name="Date 1">
+            <a:extLst>
+              <a:ext uri="{C183D7F6-B498-43B3-948B-1728B52AA6E4}">
+                <adec:decorative xmlns:adec="http://schemas.microsoft.com/office/drawing/2017/decorative" val="1"/>
+              </a:ext>
+            </a:extLst>
+          </p:cNvPr>
           <p:cNvSpPr/>
           <p:nvPr/>
         </p:nvSpPr>
@@ -5574,7 +5952,13 @@
       </p:sp>
       <p:sp>
         <p:nvSpPr>
-          <p:cNvPr id="7" name="Date 2"/>
+          <p:cNvPr id="7" name="Date 2">
+            <a:extLst>
+              <a:ext uri="{C183D7F6-B498-43B3-948B-1728B52AA6E4}">
+                <adec:decorative xmlns:adec="http://schemas.microsoft.com/office/drawing/2017/decorative" val="1"/>
+              </a:ext>
+            </a:extLst>
+          </p:cNvPr>
           <p:cNvSpPr/>
           <p:nvPr/>
         </p:nvSpPr>
@@ -5667,7 +6051,13 @@
       </p:sp>
       <p:sp>
         <p:nvSpPr>
-          <p:cNvPr id="9" name="Date 3"/>
+          <p:cNvPr id="9" name="Date 3">
+            <a:extLst>
+              <a:ext uri="{C183D7F6-B498-43B3-948B-1728B52AA6E4}">
+                <adec:decorative xmlns:adec="http://schemas.microsoft.com/office/drawing/2017/decorative" val="1"/>
+              </a:ext>
+            </a:extLst>
+          </p:cNvPr>
           <p:cNvSpPr/>
           <p:nvPr/>
         </p:nvSpPr>
@@ -5760,7 +6150,13 @@
       </p:sp>
       <p:sp>
         <p:nvSpPr>
-          <p:cNvPr id="11" name="Date 4"/>
+          <p:cNvPr id="11" name="Date 4">
+            <a:extLst>
+              <a:ext uri="{C183D7F6-B498-43B3-948B-1728B52AA6E4}">
+                <adec:decorative xmlns:adec="http://schemas.microsoft.com/office/drawing/2017/decorative" val="1"/>
+              </a:ext>
+            </a:extLst>
+          </p:cNvPr>
           <p:cNvSpPr/>
           <p:nvPr/>
         </p:nvSpPr>
@@ -5897,7 +6293,13 @@
       </p:sp>
       <p:sp>
         <p:nvSpPr>
-          <p:cNvPr id="14" name="Lift and shift"/>
+          <p:cNvPr id="14" name="Lift and shift">
+            <a:extLst>
+              <a:ext uri="{C183D7F6-B498-43B3-948B-1728B52AA6E4}">
+                <adec:decorative xmlns:adec="http://schemas.microsoft.com/office/drawing/2017/decorative" val="1"/>
+              </a:ext>
+            </a:extLst>
+          </p:cNvPr>
           <p:cNvSpPr/>
           <p:nvPr/>
         </p:nvSpPr>
@@ -5931,7 +6333,13 @@
       </p:sp>
       <p:sp>
         <p:nvSpPr>
-          <p:cNvPr id="15" name="Icon FaPlugCircleXmark"/>
+          <p:cNvPr id="15" name="Icon FaPlugCircleXmark">
+            <a:extLst>
+              <a:ext uri="{C183D7F6-B498-43B3-948B-1728B52AA6E4}">
+                <adec:decorative xmlns:adec="http://schemas.microsoft.com/office/drawing/2017/decorative" val="1"/>
+              </a:ext>
+            </a:extLst>
+          </p:cNvPr>
           <p:cNvSpPr/>
           <p:nvPr/>
         </p:nvSpPr>
@@ -5956,7 +6364,13 @@
       </p:sp>
       <p:pic>
         <p:nvPicPr>
-          <p:cNvPr id="16" name="Image 0" descr="C:\Users\whale\git\mwb-b02\presentations\_build\icons\FaPlugCircleXmark.png"/>
+          <p:cNvPr id="16" name="Image 0">
+            <a:extLst>
+              <a:ext uri="{C183D7F6-B498-43B3-948B-1728B52AA6E4}">
+                <adec:decorative xmlns:adec="http://schemas.microsoft.com/office/drawing/2017/decorative" val="1"/>
+              </a:ext>
+            </a:extLst>
+          </p:cNvPr>
           <p:cNvPicPr>
             <a:picLocks noChangeAspect="1"/>
           </p:cNvPicPr>
@@ -6105,11 +6519,11 @@
       </p:sp>
       <p:pic>
         <p:nvPicPr>
-          <p:cNvPr id="19" name="Narration">
+          <p:cNvPr id="19" name="Narration" descr="Narration for this slide; captions available">
             <a:hlinkClick r:id="" action="ppaction://media"/>
             <a:extLst>
               <a:ext uri="{FF2B5EF4-FFF2-40B4-BE49-F238E27FC236}">
-                <a16:creationId xmlns:a16="http://schemas.microsoft.com/office/drawing/2014/main" id="{09F8277D-E1F6-B5DD-9B7D-DF66A92F9D8C}"/>
+                <a16:creationId xmlns:a16="http://schemas.microsoft.com/office/drawing/2014/main" id="{8EB0D5E7-C11F-D37C-0A79-4B6EFEB60C01}"/>
               </a:ext>
             </a:extLst>
           </p:cNvPr>
@@ -6120,7 +6534,17 @@
             <a:audioFile r:link="rId2"/>
             <p:extLst>
               <p:ext uri="{DAA4B4D4-6D71-4841-9C94-3DE7FCFB9230}">
-                <p14:media xmlns:p14="http://schemas.microsoft.com/office/powerpoint/2010/main" r:embed="rId1"/>
+                <p14:media xmlns:p14="http://schemas.microsoft.com/office/powerpoint/2010/main" r:embed="rId1">
+                  <p14:extLst>
+                    <p:ext uri="{3AFAAA56-56D3-431D-BCD4-E75A35582382}">
+                      <p173:tracksInfo xmlns:p173="http://schemas.microsoft.com/office/powerpoint/2017/3/main" displayLoc="slide">
+                        <p173:trackLst>
+                          <p173:track id="{D9540E45-3C2F-4819-BDF5-3DBB9865922C}" label="English (captions)" lang="en-US" r:embed="rId7"/>
+                        </p173:trackLst>
+                      </p173:tracksInfo>
+                    </p:ext>
+                  </p14:extLst>
+                </p14:media>
               </p:ext>
             </p:extLst>
           </p:nvPr>
@@ -6287,7 +6711,13 @@
       </p:sp>
       <p:sp>
         <p:nvSpPr>
-          <p:cNvPr id="3" name="Tag What"/>
+          <p:cNvPr id="3" name="Tag What">
+            <a:extLst>
+              <a:ext uri="{C183D7F6-B498-43B3-948B-1728B52AA6E4}">
+                <adec:decorative xmlns:adec="http://schemas.microsoft.com/office/drawing/2017/decorative" val="1"/>
+              </a:ext>
+            </a:extLst>
+          </p:cNvPr>
           <p:cNvSpPr/>
           <p:nvPr/>
         </p:nvSpPr>
@@ -6369,7 +6799,7 @@
         <a:graphic>
           <a:graphicData uri="http://schemas.openxmlformats.org/drawingml/2006/table">
             <a:tbl>
-              <a:tblPr/>
+              <a:tblPr firstRow="1" bandRow="1"/>
               <a:tblGrid>
                 <a:gridCol w="1965960">
                   <a:extLst>
@@ -7865,7 +8295,13 @@
       </p:graphicFrame>
       <p:sp>
         <p:nvSpPr>
-          <p:cNvPr id="6" name="Key idea"/>
+          <p:cNvPr id="6" name="Key idea">
+            <a:extLst>
+              <a:ext uri="{C183D7F6-B498-43B3-948B-1728B52AA6E4}">
+                <adec:decorative xmlns:adec="http://schemas.microsoft.com/office/drawing/2017/decorative" val="1"/>
+              </a:ext>
+            </a:extLst>
+          </p:cNvPr>
           <p:cNvSpPr/>
           <p:nvPr/>
         </p:nvSpPr>
@@ -7899,7 +8335,13 @@
       </p:sp>
       <p:sp>
         <p:nvSpPr>
-          <p:cNvPr id="7" name="Icon FaRightLeft"/>
+          <p:cNvPr id="7" name="Icon FaRightLeft">
+            <a:extLst>
+              <a:ext uri="{C183D7F6-B498-43B3-948B-1728B52AA6E4}">
+                <adec:decorative xmlns:adec="http://schemas.microsoft.com/office/drawing/2017/decorative" val="1"/>
+              </a:ext>
+            </a:extLst>
+          </p:cNvPr>
           <p:cNvSpPr/>
           <p:nvPr/>
         </p:nvSpPr>
@@ -7924,7 +8366,13 @@
       </p:sp>
       <p:pic>
         <p:nvPicPr>
-          <p:cNvPr id="8" name="Image 0" descr="C:\Users\whale\git\mwb-b02\presentations\_build\icons\FaRightLeft.png"/>
+          <p:cNvPr id="8" name="Image 0">
+            <a:extLst>
+              <a:ext uri="{C183D7F6-B498-43B3-948B-1728B52AA6E4}">
+                <adec:decorative xmlns:adec="http://schemas.microsoft.com/office/drawing/2017/decorative" val="1"/>
+              </a:ext>
+            </a:extLst>
+          </p:cNvPr>
           <p:cNvPicPr>
             <a:picLocks noChangeAspect="1"/>
           </p:cNvPicPr>
@@ -8073,11 +8521,11 @@
       </p:sp>
       <p:pic>
         <p:nvPicPr>
-          <p:cNvPr id="11" name="Narration">
+          <p:cNvPr id="11" name="Narration" descr="Narration for this slide; captions available">
             <a:hlinkClick r:id="" action="ppaction://media"/>
             <a:extLst>
               <a:ext uri="{FF2B5EF4-FFF2-40B4-BE49-F238E27FC236}">
-                <a16:creationId xmlns:a16="http://schemas.microsoft.com/office/drawing/2014/main" id="{26B2550F-F566-7EFD-ECE2-0B3817A211A6}"/>
+                <a16:creationId xmlns:a16="http://schemas.microsoft.com/office/drawing/2014/main" id="{90D9D0F9-736B-7A11-C2FC-9F647E227C43}"/>
               </a:ext>
             </a:extLst>
           </p:cNvPr>
@@ -8088,7 +8536,17 @@
             <a:audioFile r:link="rId2"/>
             <p:extLst>
               <p:ext uri="{DAA4B4D4-6D71-4841-9C94-3DE7FCFB9230}">
-                <p14:media xmlns:p14="http://schemas.microsoft.com/office/powerpoint/2010/main" r:embed="rId1"/>
+                <p14:media xmlns:p14="http://schemas.microsoft.com/office/powerpoint/2010/main" r:embed="rId1">
+                  <p14:extLst>
+                    <p:ext uri="{3AFAAA56-56D3-431D-BCD4-E75A35582382}">
+                      <p173:tracksInfo xmlns:p173="http://schemas.microsoft.com/office/powerpoint/2017/3/main" displayLoc="slide">
+                        <p173:trackLst>
+                          <p173:track id="{617ED16A-317A-44E5-A0E0-965ABDFE19F3}" label="English (captions)" lang="en-US" r:embed="rId7"/>
+                        </p173:trackLst>
+                      </p173:tracksInfo>
+                    </p:ext>
+                  </p14:extLst>
+                </p14:media>
               </p:ext>
             </p:extLst>
           </p:nvPr>
@@ -8255,7 +8713,13 @@
       </p:sp>
       <p:sp>
         <p:nvSpPr>
-          <p:cNvPr id="3" name="Tag What"/>
+          <p:cNvPr id="3" name="Tag What">
+            <a:extLst>
+              <a:ext uri="{C183D7F6-B498-43B3-948B-1728B52AA6E4}">
+                <adec:decorative xmlns:adec="http://schemas.microsoft.com/office/drawing/2017/decorative" val="1"/>
+              </a:ext>
+            </a:extLst>
+          </p:cNvPr>
           <p:cNvSpPr/>
           <p:nvPr/>
         </p:nvSpPr>
@@ -8354,7 +8818,13 @@
       </p:sp>
       <p:sp>
         <p:nvSpPr>
-          <p:cNvPr id="6" name="Dep 1"/>
+          <p:cNvPr id="6" name="Dep 1">
+            <a:extLst>
+              <a:ext uri="{C183D7F6-B498-43B3-948B-1728B52AA6E4}">
+                <adec:decorative xmlns:adec="http://schemas.microsoft.com/office/drawing/2017/decorative" val="1"/>
+              </a:ext>
+            </a:extLst>
+          </p:cNvPr>
           <p:cNvSpPr/>
           <p:nvPr/>
         </p:nvSpPr>
@@ -8388,7 +8858,13 @@
       </p:sp>
       <p:sp>
         <p:nvSpPr>
-          <p:cNvPr id="7" name="Icon FaGlobe"/>
+          <p:cNvPr id="7" name="Icon FaGlobe">
+            <a:extLst>
+              <a:ext uri="{C183D7F6-B498-43B3-948B-1728B52AA6E4}">
+                <adec:decorative xmlns:adec="http://schemas.microsoft.com/office/drawing/2017/decorative" val="1"/>
+              </a:ext>
+            </a:extLst>
+          </p:cNvPr>
           <p:cNvSpPr/>
           <p:nvPr/>
         </p:nvSpPr>
@@ -8413,7 +8889,13 @@
       </p:sp>
       <p:pic>
         <p:nvPicPr>
-          <p:cNvPr id="8" name="Image 0" descr="C:\Users\whale\git\mwb-b02\presentations\_build\icons\FaGlobe.png"/>
+          <p:cNvPr id="8" name="Image 0">
+            <a:extLst>
+              <a:ext uri="{C183D7F6-B498-43B3-948B-1728B52AA6E4}">
+                <adec:decorative xmlns:adec="http://schemas.microsoft.com/office/drawing/2017/decorative" val="1"/>
+              </a:ext>
+            </a:extLst>
+          </p:cNvPr>
           <p:cNvPicPr>
             <a:picLocks noChangeAspect="1"/>
           </p:cNvPicPr>
@@ -8487,7 +8969,13 @@
       </p:sp>
       <p:sp>
         <p:nvSpPr>
-          <p:cNvPr id="10" name="Dep 2"/>
+          <p:cNvPr id="10" name="Dep 2">
+            <a:extLst>
+              <a:ext uri="{C183D7F6-B498-43B3-948B-1728B52AA6E4}">
+                <adec:decorative xmlns:adec="http://schemas.microsoft.com/office/drawing/2017/decorative" val="1"/>
+              </a:ext>
+            </a:extLst>
+          </p:cNvPr>
           <p:cNvSpPr/>
           <p:nvPr/>
         </p:nvSpPr>
@@ -8521,7 +9009,13 @@
       </p:sp>
       <p:sp>
         <p:nvSpPr>
-          <p:cNvPr id="11" name="Icon FaKey"/>
+          <p:cNvPr id="11" name="Icon FaKey">
+            <a:extLst>
+              <a:ext uri="{C183D7F6-B498-43B3-948B-1728B52AA6E4}">
+                <adec:decorative xmlns:adec="http://schemas.microsoft.com/office/drawing/2017/decorative" val="1"/>
+              </a:ext>
+            </a:extLst>
+          </p:cNvPr>
           <p:cNvSpPr/>
           <p:nvPr/>
         </p:nvSpPr>
@@ -8546,7 +9040,13 @@
       </p:sp>
       <p:pic>
         <p:nvPicPr>
-          <p:cNvPr id="12" name="Image 1" descr="C:\Users\whale\git\mwb-b02\presentations\_build\icons\FaKey.png"/>
+          <p:cNvPr id="12" name="Image 1">
+            <a:extLst>
+              <a:ext uri="{C183D7F6-B498-43B3-948B-1728B52AA6E4}">
+                <adec:decorative xmlns:adec="http://schemas.microsoft.com/office/drawing/2017/decorative" val="1"/>
+              </a:ext>
+            </a:extLst>
+          </p:cNvPr>
           <p:cNvPicPr>
             <a:picLocks noChangeAspect="1"/>
           </p:cNvPicPr>
@@ -8620,7 +9120,13 @@
       </p:sp>
       <p:sp>
         <p:nvSpPr>
-          <p:cNvPr id="14" name="Dep 3"/>
+          <p:cNvPr id="14" name="Dep 3">
+            <a:extLst>
+              <a:ext uri="{C183D7F6-B498-43B3-948B-1728B52AA6E4}">
+                <adec:decorative xmlns:adec="http://schemas.microsoft.com/office/drawing/2017/decorative" val="1"/>
+              </a:ext>
+            </a:extLst>
+          </p:cNvPr>
           <p:cNvSpPr/>
           <p:nvPr/>
         </p:nvSpPr>
@@ -8654,7 +9160,13 @@
       </p:sp>
       <p:sp>
         <p:nvSpPr>
-          <p:cNvPr id="15" name="Icon FaRoute"/>
+          <p:cNvPr id="15" name="Icon FaRoute">
+            <a:extLst>
+              <a:ext uri="{C183D7F6-B498-43B3-948B-1728B52AA6E4}">
+                <adec:decorative xmlns:adec="http://schemas.microsoft.com/office/drawing/2017/decorative" val="1"/>
+              </a:ext>
+            </a:extLst>
+          </p:cNvPr>
           <p:cNvSpPr/>
           <p:nvPr/>
         </p:nvSpPr>
@@ -8679,7 +9191,13 @@
       </p:sp>
       <p:pic>
         <p:nvPicPr>
-          <p:cNvPr id="16" name="Image 2" descr="C:\Users\whale\git\mwb-b02\presentations\_build\icons\FaRoute.png"/>
+          <p:cNvPr id="16" name="Image 2">
+            <a:extLst>
+              <a:ext uri="{C183D7F6-B498-43B3-948B-1728B52AA6E4}">
+                <adec:decorative xmlns:adec="http://schemas.microsoft.com/office/drawing/2017/decorative" val="1"/>
+              </a:ext>
+            </a:extLst>
+          </p:cNvPr>
           <p:cNvPicPr>
             <a:picLocks noChangeAspect="1"/>
           </p:cNvPicPr>
@@ -8753,7 +9271,13 @@
       </p:sp>
       <p:sp>
         <p:nvSpPr>
-          <p:cNvPr id="18" name="Dep 4"/>
+          <p:cNvPr id="18" name="Dep 4">
+            <a:extLst>
+              <a:ext uri="{C183D7F6-B498-43B3-948B-1728B52AA6E4}">
+                <adec:decorative xmlns:adec="http://schemas.microsoft.com/office/drawing/2017/decorative" val="1"/>
+              </a:ext>
+            </a:extLst>
+          </p:cNvPr>
           <p:cNvSpPr/>
           <p:nvPr/>
         </p:nvSpPr>
@@ -8787,7 +9311,13 @@
       </p:sp>
       <p:sp>
         <p:nvSpPr>
-          <p:cNvPr id="19" name="Icon FaPlugCircleXmark"/>
+          <p:cNvPr id="19" name="Icon FaPlugCircleXmark">
+            <a:extLst>
+              <a:ext uri="{C183D7F6-B498-43B3-948B-1728B52AA6E4}">
+                <adec:decorative xmlns:adec="http://schemas.microsoft.com/office/drawing/2017/decorative" val="1"/>
+              </a:ext>
+            </a:extLst>
+          </p:cNvPr>
           <p:cNvSpPr/>
           <p:nvPr/>
         </p:nvSpPr>
@@ -8812,7 +9342,13 @@
       </p:sp>
       <p:pic>
         <p:nvPicPr>
-          <p:cNvPr id="20" name="Image 3" descr="C:\Users\whale\git\mwb-b02\presentations\_build\icons\FaPlugCircleXmark.png"/>
+          <p:cNvPr id="20" name="Image 3">
+            <a:extLst>
+              <a:ext uri="{C183D7F6-B498-43B3-948B-1728B52AA6E4}">
+                <adec:decorative xmlns:adec="http://schemas.microsoft.com/office/drawing/2017/decorative" val="1"/>
+              </a:ext>
+            </a:extLst>
+          </p:cNvPr>
           <p:cNvPicPr>
             <a:picLocks noChangeAspect="1"/>
           </p:cNvPicPr>
@@ -8886,7 +9422,13 @@
       </p:sp>
       <p:sp>
         <p:nvSpPr>
-          <p:cNvPr id="22" name="Dep 5"/>
+          <p:cNvPr id="22" name="Dep 5">
+            <a:extLst>
+              <a:ext uri="{C183D7F6-B498-43B3-948B-1728B52AA6E4}">
+                <adec:decorative xmlns:adec="http://schemas.microsoft.com/office/drawing/2017/decorative" val="1"/>
+              </a:ext>
+            </a:extLst>
+          </p:cNvPr>
           <p:cNvSpPr/>
           <p:nvPr/>
         </p:nvSpPr>
@@ -8920,7 +9462,13 @@
       </p:sp>
       <p:sp>
         <p:nvSpPr>
-          <p:cNvPr id="23" name="Icon FaArrowsRotate"/>
+          <p:cNvPr id="23" name="Icon FaArrowsRotate">
+            <a:extLst>
+              <a:ext uri="{C183D7F6-B498-43B3-948B-1728B52AA6E4}">
+                <adec:decorative xmlns:adec="http://schemas.microsoft.com/office/drawing/2017/decorative" val="1"/>
+              </a:ext>
+            </a:extLst>
+          </p:cNvPr>
           <p:cNvSpPr/>
           <p:nvPr/>
         </p:nvSpPr>
@@ -8945,7 +9493,13 @@
       </p:sp>
       <p:pic>
         <p:nvPicPr>
-          <p:cNvPr id="24" name="Image 4" descr="C:\Users\whale\git\mwb-b02\presentations\_build\icons\FaArrowsRotate.png"/>
+          <p:cNvPr id="24" name="Image 4">
+            <a:extLst>
+              <a:ext uri="{C183D7F6-B498-43B3-948B-1728B52AA6E4}">
+                <adec:decorative xmlns:adec="http://schemas.microsoft.com/office/drawing/2017/decorative" val="1"/>
+              </a:ext>
+            </a:extLst>
+          </p:cNvPr>
           <p:cNvPicPr>
             <a:picLocks noChangeAspect="1"/>
           </p:cNvPicPr>
@@ -9019,7 +9573,13 @@
       </p:sp>
       <p:sp>
         <p:nvSpPr>
-          <p:cNvPr id="26" name="Dep 6"/>
+          <p:cNvPr id="26" name="Dep 6">
+            <a:extLst>
+              <a:ext uri="{C183D7F6-B498-43B3-948B-1728B52AA6E4}">
+                <adec:decorative xmlns:adec="http://schemas.microsoft.com/office/drawing/2017/decorative" val="1"/>
+              </a:ext>
+            </a:extLst>
+          </p:cNvPr>
           <p:cNvSpPr/>
           <p:nvPr/>
         </p:nvSpPr>
@@ -9053,7 +9613,13 @@
       </p:sp>
       <p:sp>
         <p:nvSpPr>
-          <p:cNvPr id="27" name="Icon FaLaptop"/>
+          <p:cNvPr id="27" name="Icon FaLaptop">
+            <a:extLst>
+              <a:ext uri="{C183D7F6-B498-43B3-948B-1728B52AA6E4}">
+                <adec:decorative xmlns:adec="http://schemas.microsoft.com/office/drawing/2017/decorative" val="1"/>
+              </a:ext>
+            </a:extLst>
+          </p:cNvPr>
           <p:cNvSpPr/>
           <p:nvPr/>
         </p:nvSpPr>
@@ -9078,7 +9644,13 @@
       </p:sp>
       <p:pic>
         <p:nvPicPr>
-          <p:cNvPr id="28" name="Image 5" descr="C:\Users\whale\git\mwb-b02\presentations\_build\icons\FaLaptop.png"/>
+          <p:cNvPr id="28" name="Image 5">
+            <a:extLst>
+              <a:ext uri="{C183D7F6-B498-43B3-948B-1728B52AA6E4}">
+                <adec:decorative xmlns:adec="http://schemas.microsoft.com/office/drawing/2017/decorative" val="1"/>
+              </a:ext>
+            </a:extLst>
+          </p:cNvPr>
           <p:cNvPicPr>
             <a:picLocks noChangeAspect="1"/>
           </p:cNvPicPr>
@@ -9152,7 +9724,13 @@
       </p:sp>
       <p:sp>
         <p:nvSpPr>
-          <p:cNvPr id="30" name="Dep 7"/>
+          <p:cNvPr id="30" name="Dep 7">
+            <a:extLst>
+              <a:ext uri="{C183D7F6-B498-43B3-948B-1728B52AA6E4}">
+                <adec:decorative xmlns:adec="http://schemas.microsoft.com/office/drawing/2017/decorative" val="1"/>
+              </a:ext>
+            </a:extLst>
+          </p:cNvPr>
           <p:cNvSpPr/>
           <p:nvPr/>
         </p:nvSpPr>
@@ -9186,7 +9764,13 @@
       </p:sp>
       <p:sp>
         <p:nvSpPr>
-          <p:cNvPr id="31" name="Icon FaUserClock"/>
+          <p:cNvPr id="31" name="Icon FaUserClock">
+            <a:extLst>
+              <a:ext uri="{C183D7F6-B498-43B3-948B-1728B52AA6E4}">
+                <adec:decorative xmlns:adec="http://schemas.microsoft.com/office/drawing/2017/decorative" val="1"/>
+              </a:ext>
+            </a:extLst>
+          </p:cNvPr>
           <p:cNvSpPr/>
           <p:nvPr/>
         </p:nvSpPr>
@@ -9211,7 +9795,13 @@
       </p:sp>
       <p:pic>
         <p:nvPicPr>
-          <p:cNvPr id="32" name="Image 6" descr="C:\Users\whale\git\mwb-b02\presentations\_build\icons\FaUserClock.png"/>
+          <p:cNvPr id="32" name="Image 6">
+            <a:extLst>
+              <a:ext uri="{C183D7F6-B498-43B3-948B-1728B52AA6E4}">
+                <adec:decorative xmlns:adec="http://schemas.microsoft.com/office/drawing/2017/decorative" val="1"/>
+              </a:ext>
+            </a:extLst>
+          </p:cNvPr>
           <p:cNvPicPr>
             <a:picLocks noChangeAspect="1"/>
           </p:cNvPicPr>
@@ -9285,7 +9875,13 @@
       </p:sp>
       <p:sp>
         <p:nvSpPr>
-          <p:cNvPr id="34" name="Dep 8"/>
+          <p:cNvPr id="34" name="Dep 8">
+            <a:extLst>
+              <a:ext uri="{C183D7F6-B498-43B3-948B-1728B52AA6E4}">
+                <adec:decorative xmlns:adec="http://schemas.microsoft.com/office/drawing/2017/decorative" val="1"/>
+              </a:ext>
+            </a:extLst>
+          </p:cNvPr>
           <p:cNvSpPr/>
           <p:nvPr/>
         </p:nvSpPr>
@@ -9319,7 +9915,13 @@
       </p:sp>
       <p:sp>
         <p:nvSpPr>
-          <p:cNvPr id="35" name="Icon FaDatabase"/>
+          <p:cNvPr id="35" name="Icon FaDatabase">
+            <a:extLst>
+              <a:ext uri="{C183D7F6-B498-43B3-948B-1728B52AA6E4}">
+                <adec:decorative xmlns:adec="http://schemas.microsoft.com/office/drawing/2017/decorative" val="1"/>
+              </a:ext>
+            </a:extLst>
+          </p:cNvPr>
           <p:cNvSpPr/>
           <p:nvPr/>
         </p:nvSpPr>
@@ -9344,7 +9946,13 @@
       </p:sp>
       <p:pic>
         <p:nvPicPr>
-          <p:cNvPr id="36" name="Image 7" descr="C:\Users\whale\git\mwb-b02\presentations\_build\icons\FaDatabase.png"/>
+          <p:cNvPr id="36" name="Image 7">
+            <a:extLst>
+              <a:ext uri="{C183D7F6-B498-43B3-948B-1728B52AA6E4}">
+                <adec:decorative xmlns:adec="http://schemas.microsoft.com/office/drawing/2017/decorative" val="1"/>
+              </a:ext>
+            </a:extLst>
+          </p:cNvPr>
           <p:cNvPicPr>
             <a:picLocks noChangeAspect="1"/>
           </p:cNvPicPr>
@@ -9418,7 +10026,13 @@
       </p:sp>
       <p:sp>
         <p:nvSpPr>
-          <p:cNvPr id="38" name="Adapters"/>
+          <p:cNvPr id="38" name="Adapters">
+            <a:extLst>
+              <a:ext uri="{C183D7F6-B498-43B3-948B-1728B52AA6E4}">
+                <adec:decorative xmlns:adec="http://schemas.microsoft.com/office/drawing/2017/decorative" val="1"/>
+              </a:ext>
+            </a:extLst>
+          </p:cNvPr>
           <p:cNvSpPr/>
           <p:nvPr/>
         </p:nvSpPr>
@@ -9452,7 +10066,13 @@
       </p:sp>
       <p:sp>
         <p:nvSpPr>
-          <p:cNvPr id="39" name="Icon FaCubes"/>
+          <p:cNvPr id="39" name="Icon FaCubes">
+            <a:extLst>
+              <a:ext uri="{C183D7F6-B498-43B3-948B-1728B52AA6E4}">
+                <adec:decorative xmlns:adec="http://schemas.microsoft.com/office/drawing/2017/decorative" val="1"/>
+              </a:ext>
+            </a:extLst>
+          </p:cNvPr>
           <p:cNvSpPr/>
           <p:nvPr/>
         </p:nvSpPr>
@@ -9477,7 +10097,13 @@
       </p:sp>
       <p:pic>
         <p:nvPicPr>
-          <p:cNvPr id="40" name="Image 8" descr="C:\Users\whale\git\mwb-b02\presentations\_build\icons\FaCubes.png"/>
+          <p:cNvPr id="40" name="Image 8">
+            <a:extLst>
+              <a:ext uri="{C183D7F6-B498-43B3-948B-1728B52AA6E4}">
+                <adec:decorative xmlns:adec="http://schemas.microsoft.com/office/drawing/2017/decorative" val="1"/>
+              </a:ext>
+            </a:extLst>
+          </p:cNvPr>
           <p:cNvPicPr>
             <a:picLocks noChangeAspect="1"/>
           </p:cNvPicPr>
@@ -9626,11 +10252,11 @@
       </p:sp>
       <p:pic>
         <p:nvPicPr>
-          <p:cNvPr id="44" name="Narration">
+          <p:cNvPr id="44" name="Narration" descr="Narration for this slide; captions available">
             <a:hlinkClick r:id="" action="ppaction://media"/>
             <a:extLst>
               <a:ext uri="{FF2B5EF4-FFF2-40B4-BE49-F238E27FC236}">
-                <a16:creationId xmlns:a16="http://schemas.microsoft.com/office/drawing/2014/main" id="{972C06EF-0978-BE4A-99F4-702AB56C4367}"/>
+                <a16:creationId xmlns:a16="http://schemas.microsoft.com/office/drawing/2014/main" id="{D3501289-B1E1-9854-C8ED-A126A95F8389}"/>
               </a:ext>
             </a:extLst>
           </p:cNvPr>
@@ -9641,7 +10267,17 @@
             <a:audioFile r:link="rId2"/>
             <p:extLst>
               <p:ext uri="{DAA4B4D4-6D71-4841-9C94-3DE7FCFB9230}">
-                <p14:media xmlns:p14="http://schemas.microsoft.com/office/powerpoint/2010/main" r:embed="rId1"/>
+                <p14:media xmlns:p14="http://schemas.microsoft.com/office/powerpoint/2010/main" r:embed="rId1">
+                  <p14:extLst>
+                    <p:ext uri="{3AFAAA56-56D3-431D-BCD4-E75A35582382}">
+                      <p173:tracksInfo xmlns:p173="http://schemas.microsoft.com/office/powerpoint/2017/3/main" displayLoc="slide">
+                        <p173:trackLst>
+                          <p173:track id="{F126053E-8589-421D-AB5F-8F5FED7889FF}" label="English (captions)" lang="en-US" r:embed="rId15"/>
+                        </p173:trackLst>
+                      </p173:tracksInfo>
+                    </p:ext>
+                  </p14:extLst>
+                </p14:media>
               </p:ext>
             </p:extLst>
           </p:nvPr>
@@ -9808,7 +10444,13 @@
       </p:sp>
       <p:sp>
         <p:nvSpPr>
-          <p:cNvPr id="3" name="Tag What"/>
+          <p:cNvPr id="3" name="Tag What">
+            <a:extLst>
+              <a:ext uri="{C183D7F6-B498-43B3-948B-1728B52AA6E4}">
+                <adec:decorative xmlns:adec="http://schemas.microsoft.com/office/drawing/2017/decorative" val="1"/>
+              </a:ext>
+            </a:extLst>
+          </p:cNvPr>
           <p:cNvSpPr/>
           <p:nvPr/>
         </p:nvSpPr>
@@ -9871,7 +10513,13 @@
       </p:sp>
       <p:sp>
         <p:nvSpPr>
-          <p:cNvPr id="5" name="Tier 0"/>
+          <p:cNvPr id="5" name="Tier 0">
+            <a:extLst>
+              <a:ext uri="{C183D7F6-B498-43B3-948B-1728B52AA6E4}">
+                <adec:decorative xmlns:adec="http://schemas.microsoft.com/office/drawing/2017/decorative" val="1"/>
+              </a:ext>
+            </a:extLst>
+          </p:cNvPr>
           <p:cNvSpPr/>
           <p:nvPr/>
         </p:nvSpPr>
@@ -9955,7 +10603,13 @@
       </p:sp>
       <p:sp>
         <p:nvSpPr>
-          <p:cNvPr id="7" name="Tier 1"/>
+          <p:cNvPr id="7" name="Tier 1">
+            <a:extLst>
+              <a:ext uri="{C183D7F6-B498-43B3-948B-1728B52AA6E4}">
+                <adec:decorative xmlns:adec="http://schemas.microsoft.com/office/drawing/2017/decorative" val="1"/>
+              </a:ext>
+            </a:extLst>
+          </p:cNvPr>
           <p:cNvSpPr/>
           <p:nvPr/>
         </p:nvSpPr>
@@ -10039,7 +10693,13 @@
       </p:sp>
       <p:sp>
         <p:nvSpPr>
-          <p:cNvPr id="9" name="Tier 2"/>
+          <p:cNvPr id="9" name="Tier 2">
+            <a:extLst>
+              <a:ext uri="{C183D7F6-B498-43B3-948B-1728B52AA6E4}">
+                <adec:decorative xmlns:adec="http://schemas.microsoft.com/office/drawing/2017/decorative" val="1"/>
+              </a:ext>
+            </a:extLst>
+          </p:cNvPr>
           <p:cNvSpPr/>
           <p:nvPr/>
         </p:nvSpPr>
@@ -10123,7 +10783,13 @@
       </p:sp>
       <p:sp>
         <p:nvSpPr>
-          <p:cNvPr id="11" name="Facts box"/>
+          <p:cNvPr id="11" name="Facts box">
+            <a:extLst>
+              <a:ext uri="{C183D7F6-B498-43B3-948B-1728B52AA6E4}">
+                <adec:decorative xmlns:adec="http://schemas.microsoft.com/office/drawing/2017/decorative" val="1"/>
+              </a:ext>
+            </a:extLst>
+          </p:cNvPr>
           <p:cNvSpPr/>
           <p:nvPr/>
         </p:nvSpPr>
@@ -10287,7 +10953,13 @@
       </p:sp>
       <p:sp>
         <p:nvSpPr>
-          <p:cNvPr id="14" name="Decision"/>
+          <p:cNvPr id="14" name="Decision">
+            <a:extLst>
+              <a:ext uri="{C183D7F6-B498-43B3-948B-1728B52AA6E4}">
+                <adec:decorative xmlns:adec="http://schemas.microsoft.com/office/drawing/2017/decorative" val="1"/>
+              </a:ext>
+            </a:extLst>
+          </p:cNvPr>
           <p:cNvSpPr/>
           <p:nvPr/>
         </p:nvSpPr>
@@ -10321,7 +10993,13 @@
       </p:sp>
       <p:sp>
         <p:nvSpPr>
-          <p:cNvPr id="15" name="Icon FaScaleBalanced"/>
+          <p:cNvPr id="15" name="Icon FaScaleBalanced">
+            <a:extLst>
+              <a:ext uri="{C183D7F6-B498-43B3-948B-1728B52AA6E4}">
+                <adec:decorative xmlns:adec="http://schemas.microsoft.com/office/drawing/2017/decorative" val="1"/>
+              </a:ext>
+            </a:extLst>
+          </p:cNvPr>
           <p:cNvSpPr/>
           <p:nvPr/>
         </p:nvSpPr>
@@ -10346,7 +11024,13 @@
       </p:sp>
       <p:pic>
         <p:nvPicPr>
-          <p:cNvPr id="16" name="Image 0" descr="C:\Users\whale\git\mwb-b02\presentations\_build\icons\FaScaleBalanced.png"/>
+          <p:cNvPr id="16" name="Image 0">
+            <a:extLst>
+              <a:ext uri="{C183D7F6-B498-43B3-948B-1728B52AA6E4}">
+                <adec:decorative xmlns:adec="http://schemas.microsoft.com/office/drawing/2017/decorative" val="1"/>
+              </a:ext>
+            </a:extLst>
+          </p:cNvPr>
           <p:cNvPicPr>
             <a:picLocks noChangeAspect="1"/>
           </p:cNvPicPr>
@@ -10495,11 +11179,11 @@
       </p:sp>
       <p:pic>
         <p:nvPicPr>
-          <p:cNvPr id="19" name="Narration">
+          <p:cNvPr id="19" name="Narration" descr="Narration for this slide; captions available">
             <a:hlinkClick r:id="" action="ppaction://media"/>
             <a:extLst>
               <a:ext uri="{FF2B5EF4-FFF2-40B4-BE49-F238E27FC236}">
-                <a16:creationId xmlns:a16="http://schemas.microsoft.com/office/drawing/2014/main" id="{5EDC55F9-D3E4-4C9A-FA31-C326A8E519FE}"/>
+                <a16:creationId xmlns:a16="http://schemas.microsoft.com/office/drawing/2014/main" id="{32C21EAE-4444-01E9-9C22-AD2893B43925}"/>
               </a:ext>
             </a:extLst>
           </p:cNvPr>
@@ -10510,7 +11194,17 @@
             <a:audioFile r:link="rId2"/>
             <p:extLst>
               <p:ext uri="{DAA4B4D4-6D71-4841-9C94-3DE7FCFB9230}">
-                <p14:media xmlns:p14="http://schemas.microsoft.com/office/powerpoint/2010/main" r:embed="rId1"/>
+                <p14:media xmlns:p14="http://schemas.microsoft.com/office/powerpoint/2010/main" r:embed="rId1">
+                  <p14:extLst>
+                    <p:ext uri="{3AFAAA56-56D3-431D-BCD4-E75A35582382}">
+                      <p173:tracksInfo xmlns:p173="http://schemas.microsoft.com/office/powerpoint/2017/3/main" displayLoc="slide">
+                        <p173:trackLst>
+                          <p173:track id="{8D185861-2E71-420B-89E1-3C68A34F46CF}" label="English (captions)" lang="en-US" r:embed="rId7"/>
+                        </p173:trackLst>
+                      </p173:tracksInfo>
+                    </p:ext>
+                  </p14:extLst>
+                </p14:media>
               </p:ext>
             </p:extLst>
           </p:nvPr>
@@ -10677,7 +11371,13 @@
       </p:sp>
       <p:sp>
         <p:nvSpPr>
-          <p:cNvPr id="3" name="Tag What"/>
+          <p:cNvPr id="3" name="Tag What">
+            <a:extLst>
+              <a:ext uri="{C183D7F6-B498-43B3-948B-1728B52AA6E4}">
+                <adec:decorative xmlns:adec="http://schemas.microsoft.com/office/drawing/2017/decorative" val="1"/>
+              </a:ext>
+            </a:extLst>
+          </p:cNvPr>
           <p:cNvSpPr/>
           <p:nvPr/>
         </p:nvSpPr>
@@ -10759,7 +11459,7 @@
         <a:graphic>
           <a:graphicData uri="http://schemas.openxmlformats.org/drawingml/2006/table">
             <a:tbl>
-              <a:tblPr/>
+              <a:tblPr firstRow="1" bandRow="1"/>
               <a:tblGrid>
                 <a:gridCol w="777240">
                   <a:extLst>
@@ -11844,7 +12544,13 @@
       </p:graphicFrame>
       <p:sp>
         <p:nvSpPr>
-          <p:cNvPr id="6" name="Off box"/>
+          <p:cNvPr id="6" name="Off box">
+            <a:extLst>
+              <a:ext uri="{C183D7F6-B498-43B3-948B-1728B52AA6E4}">
+                <adec:decorative xmlns:adec="http://schemas.microsoft.com/office/drawing/2017/decorative" val="1"/>
+              </a:ext>
+            </a:extLst>
+          </p:cNvPr>
           <p:cNvSpPr/>
           <p:nvPr/>
         </p:nvSpPr>
@@ -11878,7 +12584,13 @@
       </p:sp>
       <p:sp>
         <p:nvSpPr>
-          <p:cNvPr id="7" name="Icon FaLock"/>
+          <p:cNvPr id="7" name="Icon FaLock">
+            <a:extLst>
+              <a:ext uri="{C183D7F6-B498-43B3-948B-1728B52AA6E4}">
+                <adec:decorative xmlns:adec="http://schemas.microsoft.com/office/drawing/2017/decorative" val="1"/>
+              </a:ext>
+            </a:extLst>
+          </p:cNvPr>
           <p:cNvSpPr/>
           <p:nvPr/>
         </p:nvSpPr>
@@ -11903,7 +12615,13 @@
       </p:sp>
       <p:pic>
         <p:nvPicPr>
-          <p:cNvPr id="5" name="Image 0" descr="C:\Users\whale\git\mwb-b02\presentations\_build\icons\FaLock.png"/>
+          <p:cNvPr id="5" name="Image 0">
+            <a:extLst>
+              <a:ext uri="{C183D7F6-B498-43B3-948B-1728B52AA6E4}">
+                <adec:decorative xmlns:adec="http://schemas.microsoft.com/office/drawing/2017/decorative" val="1"/>
+              </a:ext>
+            </a:extLst>
+          </p:cNvPr>
           <p:cNvPicPr>
             <a:picLocks noChangeAspect="1"/>
           </p:cNvPicPr>
@@ -12056,7 +12774,13 @@
       </p:sp>
       <p:sp>
         <p:nvSpPr>
-          <p:cNvPr id="11" name="PHS"/>
+          <p:cNvPr id="11" name="PHS">
+            <a:extLst>
+              <a:ext uri="{C183D7F6-B498-43B3-948B-1728B52AA6E4}">
+                <adec:decorative xmlns:adec="http://schemas.microsoft.com/office/drawing/2017/decorative" val="1"/>
+              </a:ext>
+            </a:extLst>
+          </p:cNvPr>
           <p:cNvSpPr/>
           <p:nvPr/>
         </p:nvSpPr>
@@ -12090,7 +12814,13 @@
       </p:sp>
       <p:sp>
         <p:nvSpPr>
-          <p:cNvPr id="12" name="Icon FaKey"/>
+          <p:cNvPr id="12" name="Icon FaKey">
+            <a:extLst>
+              <a:ext uri="{C183D7F6-B498-43B3-948B-1728B52AA6E4}">
+                <adec:decorative xmlns:adec="http://schemas.microsoft.com/office/drawing/2017/decorative" val="1"/>
+              </a:ext>
+            </a:extLst>
+          </p:cNvPr>
           <p:cNvSpPr/>
           <p:nvPr/>
         </p:nvSpPr>
@@ -12115,7 +12845,13 @@
       </p:sp>
       <p:pic>
         <p:nvPicPr>
-          <p:cNvPr id="13" name="Image 1" descr="C:\Users\whale\git\mwb-b02\presentations\_build\icons\FaKey.png"/>
+          <p:cNvPr id="13" name="Image 1">
+            <a:extLst>
+              <a:ext uri="{C183D7F6-B498-43B3-948B-1728B52AA6E4}">
+                <adec:decorative xmlns:adec="http://schemas.microsoft.com/office/drawing/2017/decorative" val="1"/>
+              </a:ext>
+            </a:extLst>
+          </p:cNvPr>
           <p:cNvPicPr>
             <a:picLocks noChangeAspect="1"/>
           </p:cNvPicPr>
@@ -12264,11 +13000,11 @@
       </p:sp>
       <p:pic>
         <p:nvPicPr>
-          <p:cNvPr id="16" name="Narration">
+          <p:cNvPr id="16" name="Narration" descr="Narration for this slide; captions available">
             <a:hlinkClick r:id="" action="ppaction://media"/>
             <a:extLst>
               <a:ext uri="{FF2B5EF4-FFF2-40B4-BE49-F238E27FC236}">
-                <a16:creationId xmlns:a16="http://schemas.microsoft.com/office/drawing/2014/main" id="{257676EE-2662-5019-9027-8B2F90E43572}"/>
+                <a16:creationId xmlns:a16="http://schemas.microsoft.com/office/drawing/2014/main" id="{ACA03C29-5256-42CF-F075-17548B931568}"/>
               </a:ext>
             </a:extLst>
           </p:cNvPr>
@@ -12279,7 +13015,17 @@
             <a:audioFile r:link="rId2"/>
             <p:extLst>
               <p:ext uri="{DAA4B4D4-6D71-4841-9C94-3DE7FCFB9230}">
-                <p14:media xmlns:p14="http://schemas.microsoft.com/office/powerpoint/2010/main" r:embed="rId1"/>
+                <p14:media xmlns:p14="http://schemas.microsoft.com/office/powerpoint/2010/main" r:embed="rId1">
+                  <p14:extLst>
+                    <p:ext uri="{3AFAAA56-56D3-431D-BCD4-E75A35582382}">
+                      <p173:tracksInfo xmlns:p173="http://schemas.microsoft.com/office/powerpoint/2017/3/main" displayLoc="slide">
+                        <p173:trackLst>
+                          <p173:track id="{8C3CB176-C6C7-4D7B-90C3-0DC93E86446F}" label="English (captions)" lang="en-US" r:embed="rId8"/>
+                        </p173:trackLst>
+                      </p173:tracksInfo>
+                    </p:ext>
+                  </p14:extLst>
+                </p14:media>
               </p:ext>
             </p:extLst>
           </p:nvPr>
@@ -12446,7 +13192,13 @@
       </p:sp>
       <p:sp>
         <p:nvSpPr>
-          <p:cNvPr id="3" name="Tag Who"/>
+          <p:cNvPr id="3" name="Tag Who">
+            <a:extLst>
+              <a:ext uri="{C183D7F6-B498-43B3-948B-1728B52AA6E4}">
+                <adec:decorative xmlns:adec="http://schemas.microsoft.com/office/drawing/2017/decorative" val="1"/>
+              </a:ext>
+            </a:extLst>
+          </p:cNvPr>
           <p:cNvSpPr/>
           <p:nvPr/>
         </p:nvSpPr>
@@ -12509,7 +13261,13 @@
       </p:sp>
       <p:sp>
         <p:nvSpPr>
-          <p:cNvPr id="5" name="Who col 1"/>
+          <p:cNvPr id="5" name="Who col 1">
+            <a:extLst>
+              <a:ext uri="{C183D7F6-B498-43B3-948B-1728B52AA6E4}">
+                <adec:decorative xmlns:adec="http://schemas.microsoft.com/office/drawing/2017/decorative" val="1"/>
+              </a:ext>
+            </a:extLst>
+          </p:cNvPr>
           <p:cNvSpPr/>
           <p:nvPr/>
         </p:nvSpPr>
@@ -12543,7 +13301,13 @@
       </p:sp>
       <p:sp>
         <p:nvSpPr>
-          <p:cNvPr id="6" name="Icon FaBuildingColumns"/>
+          <p:cNvPr id="6" name="Icon FaBuildingColumns">
+            <a:extLst>
+              <a:ext uri="{C183D7F6-B498-43B3-948B-1728B52AA6E4}">
+                <adec:decorative xmlns:adec="http://schemas.microsoft.com/office/drawing/2017/decorative" val="1"/>
+              </a:ext>
+            </a:extLst>
+          </p:cNvPr>
           <p:cNvSpPr/>
           <p:nvPr/>
         </p:nvSpPr>
@@ -12568,7 +13332,13 @@
       </p:sp>
       <p:pic>
         <p:nvPicPr>
-          <p:cNvPr id="7" name="Image 0" descr="C:\Users\whale\git\mwb-b02\presentations\_build\icons\FaBuildingColumns.png"/>
+          <p:cNvPr id="7" name="Image 0">
+            <a:extLst>
+              <a:ext uri="{C183D7F6-B498-43B3-948B-1728B52AA6E4}">
+                <adec:decorative xmlns:adec="http://schemas.microsoft.com/office/drawing/2017/decorative" val="1"/>
+              </a:ext>
+            </a:extLst>
+          </p:cNvPr>
           <p:cNvPicPr>
             <a:picLocks noChangeAspect="1"/>
           </p:cNvPicPr>
@@ -12755,7 +13525,13 @@
       </p:sp>
       <p:sp>
         <p:nvSpPr>
-          <p:cNvPr id="10" name="Who col 2"/>
+          <p:cNvPr id="10" name="Who col 2">
+            <a:extLst>
+              <a:ext uri="{C183D7F6-B498-43B3-948B-1728B52AA6E4}">
+                <adec:decorative xmlns:adec="http://schemas.microsoft.com/office/drawing/2017/decorative" val="1"/>
+              </a:ext>
+            </a:extLst>
+          </p:cNvPr>
           <p:cNvSpPr/>
           <p:nvPr/>
         </p:nvSpPr>
@@ -12789,7 +13565,13 @@
       </p:sp>
       <p:sp>
         <p:nvSpPr>
-          <p:cNvPr id="11" name="Icon FaUsersGear"/>
+          <p:cNvPr id="11" name="Icon FaUsersGear">
+            <a:extLst>
+              <a:ext uri="{C183D7F6-B498-43B3-948B-1728B52AA6E4}">
+                <adec:decorative xmlns:adec="http://schemas.microsoft.com/office/drawing/2017/decorative" val="1"/>
+              </a:ext>
+            </a:extLst>
+          </p:cNvPr>
           <p:cNvSpPr/>
           <p:nvPr/>
         </p:nvSpPr>
@@ -12814,7 +13596,13 @@
       </p:sp>
       <p:pic>
         <p:nvPicPr>
-          <p:cNvPr id="12" name="Image 1" descr="C:\Users\whale\git\mwb-b02\presentations\_build\icons\FaUsersGear.png"/>
+          <p:cNvPr id="12" name="Image 1">
+            <a:extLst>
+              <a:ext uri="{C183D7F6-B498-43B3-948B-1728B52AA6E4}">
+                <adec:decorative xmlns:adec="http://schemas.microsoft.com/office/drawing/2017/decorative" val="1"/>
+              </a:ext>
+            </a:extLst>
+          </p:cNvPr>
           <p:cNvPicPr>
             <a:picLocks noChangeAspect="1"/>
           </p:cNvPicPr>
@@ -13001,7 +13789,13 @@
       </p:sp>
       <p:sp>
         <p:nvSpPr>
-          <p:cNvPr id="15" name="Who col 3"/>
+          <p:cNvPr id="15" name="Who col 3">
+            <a:extLst>
+              <a:ext uri="{C183D7F6-B498-43B3-948B-1728B52AA6E4}">
+                <adec:decorative xmlns:adec="http://schemas.microsoft.com/office/drawing/2017/decorative" val="1"/>
+              </a:ext>
+            </a:extLst>
+          </p:cNvPr>
           <p:cNvSpPr/>
           <p:nvPr/>
         </p:nvSpPr>
@@ -13035,7 +13829,13 @@
       </p:sp>
       <p:sp>
         <p:nvSpPr>
-          <p:cNvPr id="16" name="Icon FaPeopleArrows"/>
+          <p:cNvPr id="16" name="Icon FaPeopleArrows">
+            <a:extLst>
+              <a:ext uri="{C183D7F6-B498-43B3-948B-1728B52AA6E4}">
+                <adec:decorative xmlns:adec="http://schemas.microsoft.com/office/drawing/2017/decorative" val="1"/>
+              </a:ext>
+            </a:extLst>
+          </p:cNvPr>
           <p:cNvSpPr/>
           <p:nvPr/>
         </p:nvSpPr>
@@ -13060,7 +13860,13 @@
       </p:sp>
       <p:pic>
         <p:nvPicPr>
-          <p:cNvPr id="17" name="Image 2" descr="C:\Users\whale\git\mwb-b02\presentations\_build\icons\FaPeopleArrows.png"/>
+          <p:cNvPr id="17" name="Image 2">
+            <a:extLst>
+              <a:ext uri="{C183D7F6-B498-43B3-948B-1728B52AA6E4}">
+                <adec:decorative xmlns:adec="http://schemas.microsoft.com/office/drawing/2017/decorative" val="1"/>
+              </a:ext>
+            </a:extLst>
+          </p:cNvPr>
           <p:cNvPicPr>
             <a:picLocks noChangeAspect="1"/>
           </p:cNvPicPr>
@@ -13247,7 +14053,13 @@
       </p:sp>
       <p:sp>
         <p:nvSpPr>
-          <p:cNvPr id="20" name="Gap owner"/>
+          <p:cNvPr id="20" name="Gap owner">
+            <a:extLst>
+              <a:ext uri="{C183D7F6-B498-43B3-948B-1728B52AA6E4}">
+                <adec:decorative xmlns:adec="http://schemas.microsoft.com/office/drawing/2017/decorative" val="1"/>
+              </a:ext>
+            </a:extLst>
+          </p:cNvPr>
           <p:cNvSpPr/>
           <p:nvPr/>
         </p:nvSpPr>
@@ -13281,7 +14093,13 @@
       </p:sp>
       <p:sp>
         <p:nvSpPr>
-          <p:cNvPr id="21" name="Icon FaSitemap"/>
+          <p:cNvPr id="21" name="Icon FaSitemap">
+            <a:extLst>
+              <a:ext uri="{C183D7F6-B498-43B3-948B-1728B52AA6E4}">
+                <adec:decorative xmlns:adec="http://schemas.microsoft.com/office/drawing/2017/decorative" val="1"/>
+              </a:ext>
+            </a:extLst>
+          </p:cNvPr>
           <p:cNvSpPr/>
           <p:nvPr/>
         </p:nvSpPr>
@@ -13306,7 +14124,13 @@
       </p:sp>
       <p:pic>
         <p:nvPicPr>
-          <p:cNvPr id="22" name="Image 3" descr="C:\Users\whale\git\mwb-b02\presentations\_build\icons\FaSitemap.png"/>
+          <p:cNvPr id="22" name="Image 3">
+            <a:extLst>
+              <a:ext uri="{C183D7F6-B498-43B3-948B-1728B52AA6E4}">
+                <adec:decorative xmlns:adec="http://schemas.microsoft.com/office/drawing/2017/decorative" val="1"/>
+              </a:ext>
+            </a:extLst>
+          </p:cNvPr>
           <p:cNvPicPr>
             <a:picLocks noChangeAspect="1"/>
           </p:cNvPicPr>
@@ -13455,11 +14279,11 @@
       </p:sp>
       <p:pic>
         <p:nvPicPr>
-          <p:cNvPr id="26" name="Narration">
+          <p:cNvPr id="26" name="Narration" descr="Narration for this slide; captions available">
             <a:hlinkClick r:id="" action="ppaction://media"/>
             <a:extLst>
               <a:ext uri="{FF2B5EF4-FFF2-40B4-BE49-F238E27FC236}">
-                <a16:creationId xmlns:a16="http://schemas.microsoft.com/office/drawing/2014/main" id="{03C474EB-AC5E-1A49-F20A-770B60589484}"/>
+                <a16:creationId xmlns:a16="http://schemas.microsoft.com/office/drawing/2014/main" id="{98007187-1A89-AB31-E47C-B5FE8C335071}"/>
               </a:ext>
             </a:extLst>
           </p:cNvPr>
@@ -13470,7 +14294,17 @@
             <a:audioFile r:link="rId2"/>
             <p:extLst>
               <p:ext uri="{DAA4B4D4-6D71-4841-9C94-3DE7FCFB9230}">
-                <p14:media xmlns:p14="http://schemas.microsoft.com/office/powerpoint/2010/main" r:embed="rId1"/>
+                <p14:media xmlns:p14="http://schemas.microsoft.com/office/powerpoint/2010/main" r:embed="rId1">
+                  <p14:extLst>
+                    <p:ext uri="{3AFAAA56-56D3-431D-BCD4-E75A35582382}">
+                      <p173:tracksInfo xmlns:p173="http://schemas.microsoft.com/office/powerpoint/2017/3/main" displayLoc="slide">
+                        <p173:trackLst>
+                          <p173:track id="{44F6D59F-8FFE-4454-8B71-F957A869D891}" label="English (captions)" lang="en-US" r:embed="rId10"/>
+                        </p173:trackLst>
+                      </p173:tracksInfo>
+                    </p:ext>
+                  </p14:extLst>
+                </p14:media>
               </p:ext>
             </p:extLst>
           </p:nvPr>
@@ -13637,7 +14471,13 @@
       </p:sp>
       <p:sp>
         <p:nvSpPr>
-          <p:cNvPr id="3" name="Tag How"/>
+          <p:cNvPr id="3" name="Tag How">
+            <a:extLst>
+              <a:ext uri="{C183D7F6-B498-43B3-948B-1728B52AA6E4}">
+                <adec:decorative xmlns:adec="http://schemas.microsoft.com/office/drawing/2017/decorative" val="1"/>
+              </a:ext>
+            </a:extLst>
+          </p:cNvPr>
           <p:cNvSpPr/>
           <p:nvPr/>
         </p:nvSpPr>
@@ -13700,7 +14540,13 @@
       </p:sp>
       <p:sp>
         <p:nvSpPr>
-          <p:cNvPr id="5" name="Step 1"/>
+          <p:cNvPr id="5" name="Step 1">
+            <a:extLst>
+              <a:ext uri="{C183D7F6-B498-43B3-948B-1728B52AA6E4}">
+                <adec:decorative xmlns:adec="http://schemas.microsoft.com/office/drawing/2017/decorative" val="1"/>
+              </a:ext>
+            </a:extLst>
+          </p:cNvPr>
           <p:cNvSpPr/>
           <p:nvPr/>
         </p:nvSpPr>
@@ -13849,7 +14695,13 @@
       </p:sp>
       <p:sp>
         <p:nvSpPr>
-          <p:cNvPr id="8" name="Step 2"/>
+          <p:cNvPr id="8" name="Step 2">
+            <a:extLst>
+              <a:ext uri="{C183D7F6-B498-43B3-948B-1728B52AA6E4}">
+                <adec:decorative xmlns:adec="http://schemas.microsoft.com/office/drawing/2017/decorative" val="1"/>
+              </a:ext>
+            </a:extLst>
+          </p:cNvPr>
           <p:cNvSpPr/>
           <p:nvPr/>
         </p:nvSpPr>
@@ -13998,7 +14850,13 @@
       </p:sp>
       <p:sp>
         <p:nvSpPr>
-          <p:cNvPr id="11" name="Step 3"/>
+          <p:cNvPr id="11" name="Step 3">
+            <a:extLst>
+              <a:ext uri="{C183D7F6-B498-43B3-948B-1728B52AA6E4}">
+                <adec:decorative xmlns:adec="http://schemas.microsoft.com/office/drawing/2017/decorative" val="1"/>
+              </a:ext>
+            </a:extLst>
+          </p:cNvPr>
           <p:cNvSpPr/>
           <p:nvPr/>
         </p:nvSpPr>
@@ -14147,7 +15005,13 @@
       </p:sp>
       <p:sp>
         <p:nvSpPr>
-          <p:cNvPr id="14" name="Step 4"/>
+          <p:cNvPr id="14" name="Step 4">
+            <a:extLst>
+              <a:ext uri="{C183D7F6-B498-43B3-948B-1728B52AA6E4}">
+                <adec:decorative xmlns:adec="http://schemas.microsoft.com/office/drawing/2017/decorative" val="1"/>
+              </a:ext>
+            </a:extLst>
+          </p:cNvPr>
           <p:cNvSpPr/>
           <p:nvPr/>
         </p:nvSpPr>
@@ -14296,7 +15160,13 @@
       </p:sp>
       <p:sp>
         <p:nvSpPr>
-          <p:cNvPr id="17" name="Step 5"/>
+          <p:cNvPr id="17" name="Step 5">
+            <a:extLst>
+              <a:ext uri="{C183D7F6-B498-43B3-948B-1728B52AA6E4}">
+                <adec:decorative xmlns:adec="http://schemas.microsoft.com/office/drawing/2017/decorative" val="1"/>
+              </a:ext>
+            </a:extLst>
+          </p:cNvPr>
           <p:cNvSpPr/>
           <p:nvPr/>
         </p:nvSpPr>
@@ -14445,7 +15315,13 @@
       </p:sp>
       <p:sp>
         <p:nvSpPr>
-          <p:cNvPr id="20" name="Rules"/>
+          <p:cNvPr id="20" name="Rules">
+            <a:extLst>
+              <a:ext uri="{C183D7F6-B498-43B3-948B-1728B52AA6E4}">
+                <adec:decorative xmlns:adec="http://schemas.microsoft.com/office/drawing/2017/decorative" val="1"/>
+              </a:ext>
+            </a:extLst>
+          </p:cNvPr>
           <p:cNvSpPr/>
           <p:nvPr/>
         </p:nvSpPr>
@@ -14479,7 +15355,13 @@
       </p:sp>
       <p:sp>
         <p:nvSpPr>
-          <p:cNvPr id="21" name="Icon FaClipboardCheck"/>
+          <p:cNvPr id="21" name="Icon FaClipboardCheck">
+            <a:extLst>
+              <a:ext uri="{C183D7F6-B498-43B3-948B-1728B52AA6E4}">
+                <adec:decorative xmlns:adec="http://schemas.microsoft.com/office/drawing/2017/decorative" val="1"/>
+              </a:ext>
+            </a:extLst>
+          </p:cNvPr>
           <p:cNvSpPr/>
           <p:nvPr/>
         </p:nvSpPr>
@@ -14504,7 +15386,13 @@
       </p:sp>
       <p:pic>
         <p:nvPicPr>
-          <p:cNvPr id="22" name="Image 0" descr="C:\Users\whale\git\mwb-b02\presentations\_build\icons\FaClipboardCheck.png"/>
+          <p:cNvPr id="22" name="Image 0">
+            <a:extLst>
+              <a:ext uri="{C183D7F6-B498-43B3-948B-1728B52AA6E4}">
+                <adec:decorative xmlns:adec="http://schemas.microsoft.com/office/drawing/2017/decorative" val="1"/>
+              </a:ext>
+            </a:extLst>
+          </p:cNvPr>
           <p:cNvPicPr>
             <a:picLocks noChangeAspect="1"/>
           </p:cNvPicPr>
@@ -14653,11 +15541,11 @@
       </p:sp>
       <p:pic>
         <p:nvPicPr>
-          <p:cNvPr id="26" name="Narration">
+          <p:cNvPr id="26" name="Narration" descr="Narration for this slide; captions available">
             <a:hlinkClick r:id="" action="ppaction://media"/>
             <a:extLst>
               <a:ext uri="{FF2B5EF4-FFF2-40B4-BE49-F238E27FC236}">
-                <a16:creationId xmlns:a16="http://schemas.microsoft.com/office/drawing/2014/main" id="{FC004E95-8AEB-2877-6492-4BC15F2B8D4E}"/>
+                <a16:creationId xmlns:a16="http://schemas.microsoft.com/office/drawing/2014/main" id="{3C85BB17-D0B7-1719-B6DA-93325895A849}"/>
               </a:ext>
             </a:extLst>
           </p:cNvPr>
@@ -14668,7 +15556,17 @@
             <a:audioFile r:link="rId2"/>
             <p:extLst>
               <p:ext uri="{DAA4B4D4-6D71-4841-9C94-3DE7FCFB9230}">
-                <p14:media xmlns:p14="http://schemas.microsoft.com/office/powerpoint/2010/main" r:embed="rId1"/>
+                <p14:media xmlns:p14="http://schemas.microsoft.com/office/powerpoint/2010/main" r:embed="rId1">
+                  <p14:extLst>
+                    <p:ext uri="{3AFAAA56-56D3-431D-BCD4-E75A35582382}">
+                      <p173:tracksInfo xmlns:p173="http://schemas.microsoft.com/office/powerpoint/2017/3/main" displayLoc="slide">
+                        <p173:trackLst>
+                          <p173:track id="{CD570FF2-7ED6-4A7A-BCE0-A7473B1CA62C}" label="English (captions)" lang="en-US" r:embed="rId7"/>
+                        </p173:trackLst>
+                      </p173:tracksInfo>
+                    </p:ext>
+                  </p14:extLst>
+                </p14:media>
               </p:ext>
             </p:extLst>
           </p:nvPr>
@@ -14774,9 +15672,9 @@
 </file>
 
 <file path=ppt/theme/theme1.xml><?xml version="1.0" encoding="utf-8"?>
-<a:theme xmlns:a="http://schemas.openxmlformats.org/drawingml/2006/main" name="Modernization Workbook">
+<a:theme xmlns:a="http://schemas.openxmlformats.org/drawingml/2006/main" name="Federal Modernization Workbook">
   <a:themeElements>
-    <a:clrScheme name="Modernization Workbook">
+    <a:clrScheme name="Federal Modernization Workbook">
       <a:dk1>
         <a:srgbClr val="1F2A44"/>
       </a:dk1>
@@ -14814,7 +15712,7 @@
         <a:srgbClr val="334155"/>
       </a:folHlink>
     </a:clrScheme>
-    <a:fontScheme name="Modernization Workbook">
+    <a:fontScheme name="Federal Modernization Workbook">
       <a:majorFont>
         <a:latin typeface="Cambria"/>
         <a:ea typeface=""/>

</xml_diff>

<commit_message>
decks: narration that conveys each slide's intent, for all 18 book decks
Each book deck now has a narration.json: a short, conversational spoken part
per slide that explains what the slide is for and its highpoints, in the
style approved on the CyberArk research deck. The speaker notes keep their
full detail and sources for presenters; the voice no longer reads them.
narrate.py speaks narration.json when it exists and stops if a slide title
no longer matches. Re-recorded audio, captions, scripts and narrated
editions; the workbook is named once per deck.

Co-Authored-By: Claude Opus 5.5 <noreply@anthropic.com>
</commit_message>
<xml_diff>
--- a/presentations/b02-identity/B02_Identity_Narrated.pptx
+++ b/presentations/b02-identity/B02_Identity_Narrated.pptx
@@ -181,7 +181,7 @@
     </p:spTree>
     <p:extLst>
       <p:ext uri="{BB962C8B-B14F-4D97-AF65-F5344CB8AC3E}">
-        <p14:creationId xmlns:p14="http://schemas.microsoft.com/office/powerpoint/2010/main" val="1065748622"/>
+        <p14:creationId xmlns:p14="http://schemas.microsoft.com/office/powerpoint/2010/main" val="2756329138"/>
       </p:ext>
     </p:extLst>
   </p:cSld>
@@ -2252,7 +2252,7 @@
             <a:hlinkClick r:id="" action="ppaction://media"/>
             <a:extLst>
               <a:ext uri="{FF2B5EF4-FFF2-40B4-BE49-F238E27FC236}">
-                <a16:creationId xmlns:a16="http://schemas.microsoft.com/office/drawing/2014/main" id="{E10A3DA8-4BAB-1229-BE57-19FF6483D6FC}"/>
+                <a16:creationId xmlns:a16="http://schemas.microsoft.com/office/drawing/2014/main" id="{922381C0-BCC2-06D5-B28D-49FB0F472AE5}"/>
               </a:ext>
             </a:extLst>
           </p:cNvPr>
@@ -2268,7 +2268,7 @@
                     <p:ext uri="{3AFAAA56-56D3-431D-BCD4-E75A35582382}">
                       <p173:tracksInfo xmlns:p173="http://schemas.microsoft.com/office/powerpoint/2017/3/main" displayLoc="slide">
                         <p173:trackLst>
-                          <p173:track id="{071EDBD8-2327-4440-AA3A-98630AB31B04}" label="English (captions)" lang="en-US" r:embed="rId6"/>
+                          <p173:track id="{C7956B57-5DA5-4BE7-8BEA-4F403C292121}" label="English (captions)" lang="en-US" r:embed="rId6"/>
                         </p173:trackLst>
                       </p173:tracksInfo>
                     </p:ext>
@@ -2301,10 +2301,10 @@
   </p:clrMapOvr>
   <mc:AlternateContent xmlns:mc="http://schemas.openxmlformats.org/markup-compatibility/2006">
     <mc:Choice xmlns:p14="http://schemas.microsoft.com/office/powerpoint/2010/main" Requires="p14">
-      <p:transition spd="slow" p14:dur="2000" advTm="31020"/>
+      <p:transition spd="slow" p14:dur="2000" advTm="39660"/>
     </mc:Choice>
     <mc:Fallback>
-      <p:transition spd="slow" advTm="31020"/>
+      <p:transition spd="slow" advTm="39660"/>
     </mc:Fallback>
   </mc:AlternateContent>
   <p:timing>
@@ -2338,7 +2338,7 @@
                                   <p:childTnLst>
                                     <p:cmd type="call" cmd="playFrom(0.0)">
                                       <p:cBhvr>
-                                        <p:cTn id="6" dur="30024" fill="hold"/>
+                                        <p:cTn id="6" dur="35664" fill="hold"/>
                                         <p:tgtEl>
                                           <p:spTgt spid="8"/>
                                         </p:tgtEl>
@@ -3407,7 +3407,7 @@
             <a:hlinkClick r:id="" action="ppaction://media"/>
             <a:extLst>
               <a:ext uri="{FF2B5EF4-FFF2-40B4-BE49-F238E27FC236}">
-                <a16:creationId xmlns:a16="http://schemas.microsoft.com/office/drawing/2014/main" id="{D5C0BF3D-6DAE-F003-7814-3EF54D774293}"/>
+                <a16:creationId xmlns:a16="http://schemas.microsoft.com/office/drawing/2014/main" id="{44A36555-209A-4D79-3568-E01A43E04DA5}"/>
               </a:ext>
             </a:extLst>
           </p:cNvPr>
@@ -3423,7 +3423,7 @@
                     <p:ext uri="{3AFAAA56-56D3-431D-BCD4-E75A35582382}">
                       <p173:tracksInfo xmlns:p173="http://schemas.microsoft.com/office/powerpoint/2017/3/main" displayLoc="slide">
                         <p173:trackLst>
-                          <p173:track id="{B40A97EB-A6F7-463D-9A81-F96DBDAAB19C}" label="English (captions)" lang="en-US" r:embed="rId8"/>
+                          <p173:track id="{4DF5FE6E-D251-4184-AC50-9AA770B62053}" label="English (captions)" lang="en-US" r:embed="rId8"/>
                         </p173:trackLst>
                       </p173:tracksInfo>
                     </p:ext>
@@ -3456,10 +3456,10 @@
   </p:clrMapOvr>
   <mc:AlternateContent xmlns:mc="http://schemas.openxmlformats.org/markup-compatibility/2006">
     <mc:Choice xmlns:p14="http://schemas.microsoft.com/office/powerpoint/2010/main" Requires="p14">
-      <p:transition spd="slow" p14:dur="2000" advTm="82620"/>
+      <p:transition spd="slow" p14:dur="2000" advTm="55340"/>
     </mc:Choice>
     <mc:Fallback>
-      <p:transition spd="slow" advTm="82620"/>
+      <p:transition spd="slow" advTm="55340"/>
     </mc:Fallback>
   </mc:AlternateContent>
   <p:timing>
@@ -3493,7 +3493,7 @@
                                   <p:childTnLst>
                                     <p:cmd type="call" cmd="playFrom(0.0)">
                                       <p:cBhvr>
-                                        <p:cTn id="6" dur="81624" fill="hold"/>
+                                        <p:cTn id="6" dur="51336" fill="hold"/>
                                         <p:tgtEl>
                                           <p:spTgt spid="26"/>
                                         </p:tgtEl>
@@ -4474,7 +4474,7 @@
             <a:hlinkClick r:id="" action="ppaction://media"/>
             <a:extLst>
               <a:ext uri="{FF2B5EF4-FFF2-40B4-BE49-F238E27FC236}">
-                <a16:creationId xmlns:a16="http://schemas.microsoft.com/office/drawing/2014/main" id="{2D53CA0C-FBC1-39B1-E8E9-E3F12117FA56}"/>
+                <a16:creationId xmlns:a16="http://schemas.microsoft.com/office/drawing/2014/main" id="{04402C1A-F1BF-9DCD-A7B2-0B09B15DBD75}"/>
               </a:ext>
             </a:extLst>
           </p:cNvPr>
@@ -4490,7 +4490,7 @@
                     <p:ext uri="{3AFAAA56-56D3-431D-BCD4-E75A35582382}">
                       <p173:tracksInfo xmlns:p173="http://schemas.microsoft.com/office/powerpoint/2017/3/main" displayLoc="slide">
                         <p173:trackLst>
-                          <p173:track id="{17A47A3F-175E-49E6-A857-F7E3046E37E0}" label="English (captions)" lang="en-US" r:embed="rId11"/>
+                          <p173:track id="{3FC5A588-F67E-4519-A1A2-F414275DCD78}" label="English (captions)" lang="en-US" r:embed="rId11"/>
                         </p173:trackLst>
                       </p173:tracksInfo>
                     </p:ext>
@@ -4523,10 +4523,10 @@
   </p:clrMapOvr>
   <mc:AlternateContent xmlns:mc="http://schemas.openxmlformats.org/markup-compatibility/2006">
     <mc:Choice xmlns:p14="http://schemas.microsoft.com/office/powerpoint/2010/main" Requires="p14">
-      <p:transition spd="slow" p14:dur="2000" advTm="66210"/>
+      <p:transition spd="slow" p14:dur="2000" advTm="58430"/>
     </mc:Choice>
     <mc:Fallback>
-      <p:transition spd="slow" advTm="66210"/>
+      <p:transition spd="slow" advTm="58430"/>
     </mc:Fallback>
   </mc:AlternateContent>
   <p:timing>
@@ -4560,7 +4560,7 @@
                                   <p:childTnLst>
                                     <p:cmd type="call" cmd="playFrom(0.0)">
                                       <p:cBhvr>
-                                        <p:cTn id="6" dur="65208" fill="hold"/>
+                                        <p:cTn id="6" dur="54432" fill="hold"/>
                                         <p:tgtEl>
                                           <p:spTgt spid="26"/>
                                         </p:tgtEl>
@@ -5596,7 +5596,7 @@
             <a:hlinkClick r:id="" action="ppaction://media"/>
             <a:extLst>
               <a:ext uri="{FF2B5EF4-FFF2-40B4-BE49-F238E27FC236}">
-                <a16:creationId xmlns:a16="http://schemas.microsoft.com/office/drawing/2014/main" id="{8416428B-C8B8-35DB-C222-A5B18B589516}"/>
+                <a16:creationId xmlns:a16="http://schemas.microsoft.com/office/drawing/2014/main" id="{ED99CADA-8305-C459-D4E5-C18ECFAC79FB}"/>
               </a:ext>
             </a:extLst>
           </p:cNvPr>
@@ -5612,7 +5612,7 @@
                     <p:ext uri="{3AFAAA56-56D3-431D-BCD4-E75A35582382}">
                       <p173:tracksInfo xmlns:p173="http://schemas.microsoft.com/office/powerpoint/2017/3/main" displayLoc="slide">
                         <p173:trackLst>
-                          <p173:track id="{6EF174A7-C960-481F-A1CE-48ECD2A0AEB4}" label="English (captions)" lang="en-US" r:embed="rId11"/>
+                          <p173:track id="{BAD7B0A2-D966-4FF4-BD03-CF2C73A7313B}" label="English (captions)" lang="en-US" r:embed="rId11"/>
                         </p173:trackLst>
                       </p173:tracksInfo>
                     </p:ext>
@@ -5645,10 +5645,10 @@
   </p:clrMapOvr>
   <mc:AlternateContent xmlns:mc="http://schemas.openxmlformats.org/markup-compatibility/2006">
     <mc:Choice xmlns:p14="http://schemas.microsoft.com/office/powerpoint/2010/main" Requires="p14">
-      <p:transition spd="slow" p14:dur="2000" advTm="65320"/>
+      <p:transition spd="slow" p14:dur="2000" advTm="58340"/>
     </mc:Choice>
     <mc:Fallback>
-      <p:transition spd="slow" advTm="65320"/>
+      <p:transition spd="slow" advTm="58340"/>
     </mc:Fallback>
   </mc:AlternateContent>
   <p:timing>
@@ -5682,7 +5682,7 @@
                                   <p:childTnLst>
                                     <p:cmd type="call" cmd="playFrom(0.0)">
                                       <p:cBhvr>
-                                        <p:cTn id="6" dur="64320" fill="hold"/>
+                                        <p:cTn id="6" dur="54336" fill="hold"/>
                                         <p:tgtEl>
                                           <p:spTgt spid="27"/>
                                         </p:tgtEl>
@@ -6523,7 +6523,7 @@
             <a:hlinkClick r:id="" action="ppaction://media"/>
             <a:extLst>
               <a:ext uri="{FF2B5EF4-FFF2-40B4-BE49-F238E27FC236}">
-                <a16:creationId xmlns:a16="http://schemas.microsoft.com/office/drawing/2014/main" id="{EC4DD994-DAFD-A75B-DA06-A0351E4AE139}"/>
+                <a16:creationId xmlns:a16="http://schemas.microsoft.com/office/drawing/2014/main" id="{C45D06C1-FB83-816A-4BB4-2BCFE28B1BF6}"/>
               </a:ext>
             </a:extLst>
           </p:cNvPr>
@@ -6539,7 +6539,7 @@
                     <p:ext uri="{3AFAAA56-56D3-431D-BCD4-E75A35582382}">
                       <p173:tracksInfo xmlns:p173="http://schemas.microsoft.com/office/powerpoint/2017/3/main" displayLoc="slide">
                         <p173:trackLst>
-                          <p173:track id="{636BABED-2712-4DCD-AE45-5B3718D4958E}" label="English (captions)" lang="en-US" r:embed="rId7"/>
+                          <p173:track id="{4330072B-8D7F-43EE-AF6A-9FF251BD3354}" label="English (captions)" lang="en-US" r:embed="rId7"/>
                         </p173:trackLst>
                       </p173:tracksInfo>
                     </p:ext>
@@ -6572,10 +6572,10 @@
   </p:clrMapOvr>
   <mc:AlternateContent xmlns:mc="http://schemas.openxmlformats.org/markup-compatibility/2006">
     <mc:Choice xmlns:p14="http://schemas.microsoft.com/office/powerpoint/2010/main" Requires="p14">
-      <p:transition spd="slow" p14:dur="2000" advTm="87300"/>
+      <p:transition spd="slow" p14:dur="2000" advTm="67650"/>
     </mc:Choice>
     <mc:Fallback>
-      <p:transition spd="slow" advTm="87300"/>
+      <p:transition spd="slow" advTm="67650"/>
     </mc:Fallback>
   </mc:AlternateContent>
   <p:timing>
@@ -6609,7 +6609,7 @@
                                   <p:childTnLst>
                                     <p:cmd type="call" cmd="playFrom(0.0)">
                                       <p:cBhvr>
-                                        <p:cTn id="6" dur="86304" fill="hold"/>
+                                        <p:cTn id="6" dur="63648" fill="hold"/>
                                         <p:tgtEl>
                                           <p:spTgt spid="19"/>
                                         </p:tgtEl>
@@ -8525,7 +8525,7 @@
             <a:hlinkClick r:id="" action="ppaction://media"/>
             <a:extLst>
               <a:ext uri="{FF2B5EF4-FFF2-40B4-BE49-F238E27FC236}">
-                <a16:creationId xmlns:a16="http://schemas.microsoft.com/office/drawing/2014/main" id="{01387AB7-4141-AE8E-6C98-9119D9BF5775}"/>
+                <a16:creationId xmlns:a16="http://schemas.microsoft.com/office/drawing/2014/main" id="{E049CD48-4DBE-75A6-7D56-118063ACFB6E}"/>
               </a:ext>
             </a:extLst>
           </p:cNvPr>
@@ -8541,7 +8541,7 @@
                     <p:ext uri="{3AFAAA56-56D3-431D-BCD4-E75A35582382}">
                       <p173:tracksInfo xmlns:p173="http://schemas.microsoft.com/office/powerpoint/2017/3/main" displayLoc="slide">
                         <p173:trackLst>
-                          <p173:track id="{4FA43800-AE4D-4898-8E94-8FD0B6E02581}" label="English (captions)" lang="en-US" r:embed="rId7"/>
+                          <p173:track id="{C37475AE-6F50-4714-9313-906605AD850C}" label="English (captions)" lang="en-US" r:embed="rId7"/>
                         </p173:trackLst>
                       </p173:tracksInfo>
                     </p:ext>
@@ -8574,10 +8574,10 @@
   </p:clrMapOvr>
   <mc:AlternateContent xmlns:mc="http://schemas.openxmlformats.org/markup-compatibility/2006">
     <mc:Choice xmlns:p14="http://schemas.microsoft.com/office/powerpoint/2010/main" Requires="p14">
-      <p:transition spd="slow" p14:dur="2000" advTm="71680"/>
+      <p:transition spd="slow" p14:dur="2000" advTm="60040"/>
     </mc:Choice>
     <mc:Fallback>
-      <p:transition spd="slow" advTm="71680"/>
+      <p:transition spd="slow" advTm="60040"/>
     </mc:Fallback>
   </mc:AlternateContent>
   <p:timing>
@@ -8611,7 +8611,7 @@
                                   <p:childTnLst>
                                     <p:cmd type="call" cmd="playFrom(0.0)">
                                       <p:cBhvr>
-                                        <p:cTn id="6" dur="70680" fill="hold"/>
+                                        <p:cTn id="6" dur="56040" fill="hold"/>
                                         <p:tgtEl>
                                           <p:spTgt spid="11"/>
                                         </p:tgtEl>
@@ -10256,7 +10256,7 @@
             <a:hlinkClick r:id="" action="ppaction://media"/>
             <a:extLst>
               <a:ext uri="{FF2B5EF4-FFF2-40B4-BE49-F238E27FC236}">
-                <a16:creationId xmlns:a16="http://schemas.microsoft.com/office/drawing/2014/main" id="{EDFA886C-4CEF-EB9D-CC79-3F653B11C198}"/>
+                <a16:creationId xmlns:a16="http://schemas.microsoft.com/office/drawing/2014/main" id="{93A188C7-1100-B709-827B-96ADA2DF7073}"/>
               </a:ext>
             </a:extLst>
           </p:cNvPr>
@@ -10272,7 +10272,7 @@
                     <p:ext uri="{3AFAAA56-56D3-431D-BCD4-E75A35582382}">
                       <p173:tracksInfo xmlns:p173="http://schemas.microsoft.com/office/powerpoint/2017/3/main" displayLoc="slide">
                         <p173:trackLst>
-                          <p173:track id="{477BF850-9114-450F-BA0F-1DBE561C8D2B}" label="English (captions)" lang="en-US" r:embed="rId15"/>
+                          <p173:track id="{286F4057-10DF-46BD-8892-54C3DCE11477}" label="English (captions)" lang="en-US" r:embed="rId15"/>
                         </p173:trackLst>
                       </p173:tracksInfo>
                     </p:ext>
@@ -10305,10 +10305,10 @@
   </p:clrMapOvr>
   <mc:AlternateContent xmlns:mc="http://schemas.openxmlformats.org/markup-compatibility/2006">
     <mc:Choice xmlns:p14="http://schemas.microsoft.com/office/powerpoint/2010/main" Requires="p14">
-      <p:transition spd="slow" p14:dur="2000" advTm="67100"/>
+      <p:transition spd="slow" p14:dur="2000" advTm="56440"/>
     </mc:Choice>
     <mc:Fallback>
-      <p:transition spd="slow" advTm="67100"/>
+      <p:transition spd="slow" advTm="56440"/>
     </mc:Fallback>
   </mc:AlternateContent>
   <p:timing>
@@ -10342,7 +10342,7 @@
                                   <p:childTnLst>
                                     <p:cmd type="call" cmd="playFrom(0.0)">
                                       <p:cBhvr>
-                                        <p:cTn id="6" dur="66096" fill="hold"/>
+                                        <p:cTn id="6" dur="52440" fill="hold"/>
                                         <p:tgtEl>
                                           <p:spTgt spid="44"/>
                                         </p:tgtEl>
@@ -11183,7 +11183,7 @@
             <a:hlinkClick r:id="" action="ppaction://media"/>
             <a:extLst>
               <a:ext uri="{FF2B5EF4-FFF2-40B4-BE49-F238E27FC236}">
-                <a16:creationId xmlns:a16="http://schemas.microsoft.com/office/drawing/2014/main" id="{7574F8DC-65C4-8713-3A5B-4EA38BE5957F}"/>
+                <a16:creationId xmlns:a16="http://schemas.microsoft.com/office/drawing/2014/main" id="{D87C1D3E-27AC-D5D9-9AF8-9A7CA08FB0C2}"/>
               </a:ext>
             </a:extLst>
           </p:cNvPr>
@@ -11199,7 +11199,7 @@
                     <p:ext uri="{3AFAAA56-56D3-431D-BCD4-E75A35582382}">
                       <p173:tracksInfo xmlns:p173="http://schemas.microsoft.com/office/powerpoint/2017/3/main" displayLoc="slide">
                         <p173:trackLst>
-                          <p173:track id="{B857DA69-2881-4B11-96B6-4F6D818F5FC7}" label="English (captions)" lang="en-US" r:embed="rId7"/>
+                          <p173:track id="{EA116692-9061-4428-8C18-34F71A6EAB4A}" label="English (captions)" lang="en-US" r:embed="rId7"/>
                         </p173:trackLst>
                       </p173:tracksInfo>
                     </p:ext>
@@ -11232,10 +11232,10 @@
   </p:clrMapOvr>
   <mc:AlternateContent xmlns:mc="http://schemas.openxmlformats.org/markup-compatibility/2006">
     <mc:Choice xmlns:p14="http://schemas.microsoft.com/office/powerpoint/2010/main" Requires="p14">
-      <p:transition spd="slow" p14:dur="2000" advTm="73240"/>
+      <p:transition spd="slow" p14:dur="2000" advTm="57740"/>
     </mc:Choice>
     <mc:Fallback>
-      <p:transition spd="slow" advTm="73240"/>
+      <p:transition spd="slow" advTm="57740"/>
     </mc:Fallback>
   </mc:AlternateContent>
   <p:timing>
@@ -11269,7 +11269,7 @@
                                   <p:childTnLst>
                                     <p:cmd type="call" cmd="playFrom(0.0)">
                                       <p:cBhvr>
-                                        <p:cTn id="6" dur="72240" fill="hold"/>
+                                        <p:cTn id="6" dur="53736" fill="hold"/>
                                         <p:tgtEl>
                                           <p:spTgt spid="19"/>
                                         </p:tgtEl>
@@ -13004,7 +13004,7 @@
             <a:hlinkClick r:id="" action="ppaction://media"/>
             <a:extLst>
               <a:ext uri="{FF2B5EF4-FFF2-40B4-BE49-F238E27FC236}">
-                <a16:creationId xmlns:a16="http://schemas.microsoft.com/office/drawing/2014/main" id="{C21D75C5-1097-B0AB-871C-BF67A1056536}"/>
+                <a16:creationId xmlns:a16="http://schemas.microsoft.com/office/drawing/2014/main" id="{B162AA53-323B-2E80-0465-EF37DFEF2964}"/>
               </a:ext>
             </a:extLst>
           </p:cNvPr>
@@ -13020,7 +13020,7 @@
                     <p:ext uri="{3AFAAA56-56D3-431D-BCD4-E75A35582382}">
                       <p173:tracksInfo xmlns:p173="http://schemas.microsoft.com/office/powerpoint/2017/3/main" displayLoc="slide">
                         <p173:trackLst>
-                          <p173:track id="{4FF4047C-41BE-40F9-8C1B-F69BB2F0540E}" label="English (captions)" lang="en-US" r:embed="rId8"/>
+                          <p173:track id="{A3657677-F906-4DCB-A5B0-C0335DA06403}" label="English (captions)" lang="en-US" r:embed="rId8"/>
                         </p173:trackLst>
                       </p173:tracksInfo>
                     </p:ext>
@@ -13053,10 +13053,10 @@
   </p:clrMapOvr>
   <mc:AlternateContent xmlns:mc="http://schemas.openxmlformats.org/markup-compatibility/2006">
     <mc:Choice xmlns:p14="http://schemas.microsoft.com/office/powerpoint/2010/main" Requires="p14">
-      <p:transition spd="slow" p14:dur="2000" advTm="90830"/>
+      <p:transition spd="slow" p14:dur="2000" advTm="61530"/>
     </mc:Choice>
     <mc:Fallback>
-      <p:transition spd="slow" advTm="90830"/>
+      <p:transition spd="slow" advTm="61530"/>
     </mc:Fallback>
   </mc:AlternateContent>
   <p:timing>
@@ -13090,7 +13090,7 @@
                                   <p:childTnLst>
                                     <p:cmd type="call" cmd="playFrom(0.0)">
                                       <p:cBhvr>
-                                        <p:cTn id="6" dur="89832" fill="hold"/>
+                                        <p:cTn id="6" dur="57528" fill="hold"/>
                                         <p:tgtEl>
                                           <p:spTgt spid="16"/>
                                         </p:tgtEl>
@@ -14283,7 +14283,7 @@
             <a:hlinkClick r:id="" action="ppaction://media"/>
             <a:extLst>
               <a:ext uri="{FF2B5EF4-FFF2-40B4-BE49-F238E27FC236}">
-                <a16:creationId xmlns:a16="http://schemas.microsoft.com/office/drawing/2014/main" id="{F356A936-BAEE-807C-AD60-C30E0618DEE2}"/>
+                <a16:creationId xmlns:a16="http://schemas.microsoft.com/office/drawing/2014/main" id="{E18A00F5-17AE-951A-8E69-3261B1C2EA36}"/>
               </a:ext>
             </a:extLst>
           </p:cNvPr>
@@ -14299,7 +14299,7 @@
                     <p:ext uri="{3AFAAA56-56D3-431D-BCD4-E75A35582382}">
                       <p173:tracksInfo xmlns:p173="http://schemas.microsoft.com/office/powerpoint/2017/3/main" displayLoc="slide">
                         <p173:trackLst>
-                          <p173:track id="{BB58C456-90E7-4019-932A-4A652325960B}" label="English (captions)" lang="en-US" r:embed="rId10"/>
+                          <p173:track id="{B89E4740-8E1C-4605-A6DA-D3CACFC2905F}" label="English (captions)" lang="en-US" r:embed="rId10"/>
                         </p173:trackLst>
                       </p173:tracksInfo>
                     </p:ext>
@@ -14332,10 +14332,10 @@
   </p:clrMapOvr>
   <mc:AlternateContent xmlns:mc="http://schemas.openxmlformats.org/markup-compatibility/2006">
     <mc:Choice xmlns:p14="http://schemas.microsoft.com/office/powerpoint/2010/main" Requires="p14">
-      <p:transition spd="slow" p14:dur="2000" advTm="75400"/>
+      <p:transition spd="slow" p14:dur="2000" advTm="60710"/>
     </mc:Choice>
     <mc:Fallback>
-      <p:transition spd="slow" advTm="75400"/>
+      <p:transition spd="slow" advTm="60710"/>
     </mc:Fallback>
   </mc:AlternateContent>
   <p:timing>
@@ -14369,7 +14369,7 @@
                                   <p:childTnLst>
                                     <p:cmd type="call" cmd="playFrom(0.0)">
                                       <p:cBhvr>
-                                        <p:cTn id="6" dur="74400" fill="hold"/>
+                                        <p:cTn id="6" dur="56712" fill="hold"/>
                                         <p:tgtEl>
                                           <p:spTgt spid="26"/>
                                         </p:tgtEl>
@@ -15545,7 +15545,7 @@
             <a:hlinkClick r:id="" action="ppaction://media"/>
             <a:extLst>
               <a:ext uri="{FF2B5EF4-FFF2-40B4-BE49-F238E27FC236}">
-                <a16:creationId xmlns:a16="http://schemas.microsoft.com/office/drawing/2014/main" id="{D5B15840-29F6-AB29-AA91-11376D6F3DDF}"/>
+                <a16:creationId xmlns:a16="http://schemas.microsoft.com/office/drawing/2014/main" id="{74370BF2-7285-7FF2-8A49-82D03EE2BD84}"/>
               </a:ext>
             </a:extLst>
           </p:cNvPr>
@@ -15561,7 +15561,7 @@
                     <p:ext uri="{3AFAAA56-56D3-431D-BCD4-E75A35582382}">
                       <p173:tracksInfo xmlns:p173="http://schemas.microsoft.com/office/powerpoint/2017/3/main" displayLoc="slide">
                         <p173:trackLst>
-                          <p173:track id="{85479FBA-7693-4A5F-BC06-4F97083406D3}" label="English (captions)" lang="en-US" r:embed="rId7"/>
+                          <p173:track id="{DF4B0695-B0AB-406B-8D28-3256E33261ED}" label="English (captions)" lang="en-US" r:embed="rId7"/>
                         </p173:trackLst>
                       </p173:tracksInfo>
                     </p:ext>
@@ -15594,10 +15594,10 @@
   </p:clrMapOvr>
   <mc:AlternateContent xmlns:mc="http://schemas.openxmlformats.org/markup-compatibility/2006">
     <mc:Choice xmlns:p14="http://schemas.microsoft.com/office/powerpoint/2010/main" Requires="p14">
-      <p:transition spd="slow" p14:dur="2000" advTm="78140"/>
+      <p:transition spd="slow" p14:dur="2000" advTm="60230"/>
     </mc:Choice>
     <mc:Fallback>
-      <p:transition spd="slow" advTm="78140"/>
+      <p:transition spd="slow" advTm="60230"/>
     </mc:Fallback>
   </mc:AlternateContent>
   <p:timing>
@@ -15631,7 +15631,7 @@
                                   <p:childTnLst>
                                     <p:cmd type="call" cmd="playFrom(0.0)">
                                       <p:cBhvr>
-                                        <p:cTn id="6" dur="77136" fill="hold"/>
+                                        <p:cTn id="6" dur="56232" fill="hold"/>
                                         <p:tgtEl>
                                           <p:spTgt spid="26"/>
                                         </p:tgtEl>

</xml_diff>

<commit_message>
decks: narration that conveys each slide's intent, for all 18 book decks (#121)
Each book deck now has a narration.json: a short, conversational spoken part
per slide that explains what the slide is for and its highpoints, in the
style approved on the CyberArk research deck. The speaker notes keep their
full detail and sources for presenters; the voice no longer reads them.
narrate.py speaks narration.json when it exists and stops if a slide title
no longer matches. Re-recorded audio, captions, scripts and narrated
editions; the workbook is named once per deck.

Co-authored-by: Claude Opus 5.5 <noreply@anthropic.com>
</commit_message>
<xml_diff>
--- a/presentations/b02-identity/B02_Identity_Narrated.pptx
+++ b/presentations/b02-identity/B02_Identity_Narrated.pptx
@@ -181,7 +181,7 @@
     </p:spTree>
     <p:extLst>
       <p:ext uri="{BB962C8B-B14F-4D97-AF65-F5344CB8AC3E}">
-        <p14:creationId xmlns:p14="http://schemas.microsoft.com/office/powerpoint/2010/main" val="1065748622"/>
+        <p14:creationId xmlns:p14="http://schemas.microsoft.com/office/powerpoint/2010/main" val="2756329138"/>
       </p:ext>
     </p:extLst>
   </p:cSld>
@@ -2252,7 +2252,7 @@
             <a:hlinkClick r:id="" action="ppaction://media"/>
             <a:extLst>
               <a:ext uri="{FF2B5EF4-FFF2-40B4-BE49-F238E27FC236}">
-                <a16:creationId xmlns:a16="http://schemas.microsoft.com/office/drawing/2014/main" id="{E10A3DA8-4BAB-1229-BE57-19FF6483D6FC}"/>
+                <a16:creationId xmlns:a16="http://schemas.microsoft.com/office/drawing/2014/main" id="{922381C0-BCC2-06D5-B28D-49FB0F472AE5}"/>
               </a:ext>
             </a:extLst>
           </p:cNvPr>
@@ -2268,7 +2268,7 @@
                     <p:ext uri="{3AFAAA56-56D3-431D-BCD4-E75A35582382}">
                       <p173:tracksInfo xmlns:p173="http://schemas.microsoft.com/office/powerpoint/2017/3/main" displayLoc="slide">
                         <p173:trackLst>
-                          <p173:track id="{071EDBD8-2327-4440-AA3A-98630AB31B04}" label="English (captions)" lang="en-US" r:embed="rId6"/>
+                          <p173:track id="{C7956B57-5DA5-4BE7-8BEA-4F403C292121}" label="English (captions)" lang="en-US" r:embed="rId6"/>
                         </p173:trackLst>
                       </p173:tracksInfo>
                     </p:ext>
@@ -2301,10 +2301,10 @@
   </p:clrMapOvr>
   <mc:AlternateContent xmlns:mc="http://schemas.openxmlformats.org/markup-compatibility/2006">
     <mc:Choice xmlns:p14="http://schemas.microsoft.com/office/powerpoint/2010/main" Requires="p14">
-      <p:transition spd="slow" p14:dur="2000" advTm="31020"/>
+      <p:transition spd="slow" p14:dur="2000" advTm="39660"/>
     </mc:Choice>
     <mc:Fallback>
-      <p:transition spd="slow" advTm="31020"/>
+      <p:transition spd="slow" advTm="39660"/>
     </mc:Fallback>
   </mc:AlternateContent>
   <p:timing>
@@ -2338,7 +2338,7 @@
                                   <p:childTnLst>
                                     <p:cmd type="call" cmd="playFrom(0.0)">
                                       <p:cBhvr>
-                                        <p:cTn id="6" dur="30024" fill="hold"/>
+                                        <p:cTn id="6" dur="35664" fill="hold"/>
                                         <p:tgtEl>
                                           <p:spTgt spid="8"/>
                                         </p:tgtEl>
@@ -3407,7 +3407,7 @@
             <a:hlinkClick r:id="" action="ppaction://media"/>
             <a:extLst>
               <a:ext uri="{FF2B5EF4-FFF2-40B4-BE49-F238E27FC236}">
-                <a16:creationId xmlns:a16="http://schemas.microsoft.com/office/drawing/2014/main" id="{D5C0BF3D-6DAE-F003-7814-3EF54D774293}"/>
+                <a16:creationId xmlns:a16="http://schemas.microsoft.com/office/drawing/2014/main" id="{44A36555-209A-4D79-3568-E01A43E04DA5}"/>
               </a:ext>
             </a:extLst>
           </p:cNvPr>
@@ -3423,7 +3423,7 @@
                     <p:ext uri="{3AFAAA56-56D3-431D-BCD4-E75A35582382}">
                       <p173:tracksInfo xmlns:p173="http://schemas.microsoft.com/office/powerpoint/2017/3/main" displayLoc="slide">
                         <p173:trackLst>
-                          <p173:track id="{B40A97EB-A6F7-463D-9A81-F96DBDAAB19C}" label="English (captions)" lang="en-US" r:embed="rId8"/>
+                          <p173:track id="{4DF5FE6E-D251-4184-AC50-9AA770B62053}" label="English (captions)" lang="en-US" r:embed="rId8"/>
                         </p173:trackLst>
                       </p173:tracksInfo>
                     </p:ext>
@@ -3456,10 +3456,10 @@
   </p:clrMapOvr>
   <mc:AlternateContent xmlns:mc="http://schemas.openxmlformats.org/markup-compatibility/2006">
     <mc:Choice xmlns:p14="http://schemas.microsoft.com/office/powerpoint/2010/main" Requires="p14">
-      <p:transition spd="slow" p14:dur="2000" advTm="82620"/>
+      <p:transition spd="slow" p14:dur="2000" advTm="55340"/>
     </mc:Choice>
     <mc:Fallback>
-      <p:transition spd="slow" advTm="82620"/>
+      <p:transition spd="slow" advTm="55340"/>
     </mc:Fallback>
   </mc:AlternateContent>
   <p:timing>
@@ -3493,7 +3493,7 @@
                                   <p:childTnLst>
                                     <p:cmd type="call" cmd="playFrom(0.0)">
                                       <p:cBhvr>
-                                        <p:cTn id="6" dur="81624" fill="hold"/>
+                                        <p:cTn id="6" dur="51336" fill="hold"/>
                                         <p:tgtEl>
                                           <p:spTgt spid="26"/>
                                         </p:tgtEl>
@@ -4474,7 +4474,7 @@
             <a:hlinkClick r:id="" action="ppaction://media"/>
             <a:extLst>
               <a:ext uri="{FF2B5EF4-FFF2-40B4-BE49-F238E27FC236}">
-                <a16:creationId xmlns:a16="http://schemas.microsoft.com/office/drawing/2014/main" id="{2D53CA0C-FBC1-39B1-E8E9-E3F12117FA56}"/>
+                <a16:creationId xmlns:a16="http://schemas.microsoft.com/office/drawing/2014/main" id="{04402C1A-F1BF-9DCD-A7B2-0B09B15DBD75}"/>
               </a:ext>
             </a:extLst>
           </p:cNvPr>
@@ -4490,7 +4490,7 @@
                     <p:ext uri="{3AFAAA56-56D3-431D-BCD4-E75A35582382}">
                       <p173:tracksInfo xmlns:p173="http://schemas.microsoft.com/office/powerpoint/2017/3/main" displayLoc="slide">
                         <p173:trackLst>
-                          <p173:track id="{17A47A3F-175E-49E6-A857-F7E3046E37E0}" label="English (captions)" lang="en-US" r:embed="rId11"/>
+                          <p173:track id="{3FC5A588-F67E-4519-A1A2-F414275DCD78}" label="English (captions)" lang="en-US" r:embed="rId11"/>
                         </p173:trackLst>
                       </p173:tracksInfo>
                     </p:ext>
@@ -4523,10 +4523,10 @@
   </p:clrMapOvr>
   <mc:AlternateContent xmlns:mc="http://schemas.openxmlformats.org/markup-compatibility/2006">
     <mc:Choice xmlns:p14="http://schemas.microsoft.com/office/powerpoint/2010/main" Requires="p14">
-      <p:transition spd="slow" p14:dur="2000" advTm="66210"/>
+      <p:transition spd="slow" p14:dur="2000" advTm="58430"/>
     </mc:Choice>
     <mc:Fallback>
-      <p:transition spd="slow" advTm="66210"/>
+      <p:transition spd="slow" advTm="58430"/>
     </mc:Fallback>
   </mc:AlternateContent>
   <p:timing>
@@ -4560,7 +4560,7 @@
                                   <p:childTnLst>
                                     <p:cmd type="call" cmd="playFrom(0.0)">
                                       <p:cBhvr>
-                                        <p:cTn id="6" dur="65208" fill="hold"/>
+                                        <p:cTn id="6" dur="54432" fill="hold"/>
                                         <p:tgtEl>
                                           <p:spTgt spid="26"/>
                                         </p:tgtEl>
@@ -5596,7 +5596,7 @@
             <a:hlinkClick r:id="" action="ppaction://media"/>
             <a:extLst>
               <a:ext uri="{FF2B5EF4-FFF2-40B4-BE49-F238E27FC236}">
-                <a16:creationId xmlns:a16="http://schemas.microsoft.com/office/drawing/2014/main" id="{8416428B-C8B8-35DB-C222-A5B18B589516}"/>
+                <a16:creationId xmlns:a16="http://schemas.microsoft.com/office/drawing/2014/main" id="{ED99CADA-8305-C459-D4E5-C18ECFAC79FB}"/>
               </a:ext>
             </a:extLst>
           </p:cNvPr>
@@ -5612,7 +5612,7 @@
                     <p:ext uri="{3AFAAA56-56D3-431D-BCD4-E75A35582382}">
                       <p173:tracksInfo xmlns:p173="http://schemas.microsoft.com/office/powerpoint/2017/3/main" displayLoc="slide">
                         <p173:trackLst>
-                          <p173:track id="{6EF174A7-C960-481F-A1CE-48ECD2A0AEB4}" label="English (captions)" lang="en-US" r:embed="rId11"/>
+                          <p173:track id="{BAD7B0A2-D966-4FF4-BD03-CF2C73A7313B}" label="English (captions)" lang="en-US" r:embed="rId11"/>
                         </p173:trackLst>
                       </p173:tracksInfo>
                     </p:ext>
@@ -5645,10 +5645,10 @@
   </p:clrMapOvr>
   <mc:AlternateContent xmlns:mc="http://schemas.openxmlformats.org/markup-compatibility/2006">
     <mc:Choice xmlns:p14="http://schemas.microsoft.com/office/powerpoint/2010/main" Requires="p14">
-      <p:transition spd="slow" p14:dur="2000" advTm="65320"/>
+      <p:transition spd="slow" p14:dur="2000" advTm="58340"/>
     </mc:Choice>
     <mc:Fallback>
-      <p:transition spd="slow" advTm="65320"/>
+      <p:transition spd="slow" advTm="58340"/>
     </mc:Fallback>
   </mc:AlternateContent>
   <p:timing>
@@ -5682,7 +5682,7 @@
                                   <p:childTnLst>
                                     <p:cmd type="call" cmd="playFrom(0.0)">
                                       <p:cBhvr>
-                                        <p:cTn id="6" dur="64320" fill="hold"/>
+                                        <p:cTn id="6" dur="54336" fill="hold"/>
                                         <p:tgtEl>
                                           <p:spTgt spid="27"/>
                                         </p:tgtEl>
@@ -6523,7 +6523,7 @@
             <a:hlinkClick r:id="" action="ppaction://media"/>
             <a:extLst>
               <a:ext uri="{FF2B5EF4-FFF2-40B4-BE49-F238E27FC236}">
-                <a16:creationId xmlns:a16="http://schemas.microsoft.com/office/drawing/2014/main" id="{EC4DD994-DAFD-A75B-DA06-A0351E4AE139}"/>
+                <a16:creationId xmlns:a16="http://schemas.microsoft.com/office/drawing/2014/main" id="{C45D06C1-FB83-816A-4BB4-2BCFE28B1BF6}"/>
               </a:ext>
             </a:extLst>
           </p:cNvPr>
@@ -6539,7 +6539,7 @@
                     <p:ext uri="{3AFAAA56-56D3-431D-BCD4-E75A35582382}">
                       <p173:tracksInfo xmlns:p173="http://schemas.microsoft.com/office/powerpoint/2017/3/main" displayLoc="slide">
                         <p173:trackLst>
-                          <p173:track id="{636BABED-2712-4DCD-AE45-5B3718D4958E}" label="English (captions)" lang="en-US" r:embed="rId7"/>
+                          <p173:track id="{4330072B-8D7F-43EE-AF6A-9FF251BD3354}" label="English (captions)" lang="en-US" r:embed="rId7"/>
                         </p173:trackLst>
                       </p173:tracksInfo>
                     </p:ext>
@@ -6572,10 +6572,10 @@
   </p:clrMapOvr>
   <mc:AlternateContent xmlns:mc="http://schemas.openxmlformats.org/markup-compatibility/2006">
     <mc:Choice xmlns:p14="http://schemas.microsoft.com/office/powerpoint/2010/main" Requires="p14">
-      <p:transition spd="slow" p14:dur="2000" advTm="87300"/>
+      <p:transition spd="slow" p14:dur="2000" advTm="67650"/>
     </mc:Choice>
     <mc:Fallback>
-      <p:transition spd="slow" advTm="87300"/>
+      <p:transition spd="slow" advTm="67650"/>
     </mc:Fallback>
   </mc:AlternateContent>
   <p:timing>
@@ -6609,7 +6609,7 @@
                                   <p:childTnLst>
                                     <p:cmd type="call" cmd="playFrom(0.0)">
                                       <p:cBhvr>
-                                        <p:cTn id="6" dur="86304" fill="hold"/>
+                                        <p:cTn id="6" dur="63648" fill="hold"/>
                                         <p:tgtEl>
                                           <p:spTgt spid="19"/>
                                         </p:tgtEl>
@@ -8525,7 +8525,7 @@
             <a:hlinkClick r:id="" action="ppaction://media"/>
             <a:extLst>
               <a:ext uri="{FF2B5EF4-FFF2-40B4-BE49-F238E27FC236}">
-                <a16:creationId xmlns:a16="http://schemas.microsoft.com/office/drawing/2014/main" id="{01387AB7-4141-AE8E-6C98-9119D9BF5775}"/>
+                <a16:creationId xmlns:a16="http://schemas.microsoft.com/office/drawing/2014/main" id="{E049CD48-4DBE-75A6-7D56-118063ACFB6E}"/>
               </a:ext>
             </a:extLst>
           </p:cNvPr>
@@ -8541,7 +8541,7 @@
                     <p:ext uri="{3AFAAA56-56D3-431D-BCD4-E75A35582382}">
                       <p173:tracksInfo xmlns:p173="http://schemas.microsoft.com/office/powerpoint/2017/3/main" displayLoc="slide">
                         <p173:trackLst>
-                          <p173:track id="{4FA43800-AE4D-4898-8E94-8FD0B6E02581}" label="English (captions)" lang="en-US" r:embed="rId7"/>
+                          <p173:track id="{C37475AE-6F50-4714-9313-906605AD850C}" label="English (captions)" lang="en-US" r:embed="rId7"/>
                         </p173:trackLst>
                       </p173:tracksInfo>
                     </p:ext>
@@ -8574,10 +8574,10 @@
   </p:clrMapOvr>
   <mc:AlternateContent xmlns:mc="http://schemas.openxmlformats.org/markup-compatibility/2006">
     <mc:Choice xmlns:p14="http://schemas.microsoft.com/office/powerpoint/2010/main" Requires="p14">
-      <p:transition spd="slow" p14:dur="2000" advTm="71680"/>
+      <p:transition spd="slow" p14:dur="2000" advTm="60040"/>
     </mc:Choice>
     <mc:Fallback>
-      <p:transition spd="slow" advTm="71680"/>
+      <p:transition spd="slow" advTm="60040"/>
     </mc:Fallback>
   </mc:AlternateContent>
   <p:timing>
@@ -8611,7 +8611,7 @@
                                   <p:childTnLst>
                                     <p:cmd type="call" cmd="playFrom(0.0)">
                                       <p:cBhvr>
-                                        <p:cTn id="6" dur="70680" fill="hold"/>
+                                        <p:cTn id="6" dur="56040" fill="hold"/>
                                         <p:tgtEl>
                                           <p:spTgt spid="11"/>
                                         </p:tgtEl>
@@ -10256,7 +10256,7 @@
             <a:hlinkClick r:id="" action="ppaction://media"/>
             <a:extLst>
               <a:ext uri="{FF2B5EF4-FFF2-40B4-BE49-F238E27FC236}">
-                <a16:creationId xmlns:a16="http://schemas.microsoft.com/office/drawing/2014/main" id="{EDFA886C-4CEF-EB9D-CC79-3F653B11C198}"/>
+                <a16:creationId xmlns:a16="http://schemas.microsoft.com/office/drawing/2014/main" id="{93A188C7-1100-B709-827B-96ADA2DF7073}"/>
               </a:ext>
             </a:extLst>
           </p:cNvPr>
@@ -10272,7 +10272,7 @@
                     <p:ext uri="{3AFAAA56-56D3-431D-BCD4-E75A35582382}">
                       <p173:tracksInfo xmlns:p173="http://schemas.microsoft.com/office/powerpoint/2017/3/main" displayLoc="slide">
                         <p173:trackLst>
-                          <p173:track id="{477BF850-9114-450F-BA0F-1DBE561C8D2B}" label="English (captions)" lang="en-US" r:embed="rId15"/>
+                          <p173:track id="{286F4057-10DF-46BD-8892-54C3DCE11477}" label="English (captions)" lang="en-US" r:embed="rId15"/>
                         </p173:trackLst>
                       </p173:tracksInfo>
                     </p:ext>
@@ -10305,10 +10305,10 @@
   </p:clrMapOvr>
   <mc:AlternateContent xmlns:mc="http://schemas.openxmlformats.org/markup-compatibility/2006">
     <mc:Choice xmlns:p14="http://schemas.microsoft.com/office/powerpoint/2010/main" Requires="p14">
-      <p:transition spd="slow" p14:dur="2000" advTm="67100"/>
+      <p:transition spd="slow" p14:dur="2000" advTm="56440"/>
     </mc:Choice>
     <mc:Fallback>
-      <p:transition spd="slow" advTm="67100"/>
+      <p:transition spd="slow" advTm="56440"/>
     </mc:Fallback>
   </mc:AlternateContent>
   <p:timing>
@@ -10342,7 +10342,7 @@
                                   <p:childTnLst>
                                     <p:cmd type="call" cmd="playFrom(0.0)">
                                       <p:cBhvr>
-                                        <p:cTn id="6" dur="66096" fill="hold"/>
+                                        <p:cTn id="6" dur="52440" fill="hold"/>
                                         <p:tgtEl>
                                           <p:spTgt spid="44"/>
                                         </p:tgtEl>
@@ -11183,7 +11183,7 @@
             <a:hlinkClick r:id="" action="ppaction://media"/>
             <a:extLst>
               <a:ext uri="{FF2B5EF4-FFF2-40B4-BE49-F238E27FC236}">
-                <a16:creationId xmlns:a16="http://schemas.microsoft.com/office/drawing/2014/main" id="{7574F8DC-65C4-8713-3A5B-4EA38BE5957F}"/>
+                <a16:creationId xmlns:a16="http://schemas.microsoft.com/office/drawing/2014/main" id="{D87C1D3E-27AC-D5D9-9AF8-9A7CA08FB0C2}"/>
               </a:ext>
             </a:extLst>
           </p:cNvPr>
@@ -11199,7 +11199,7 @@
                     <p:ext uri="{3AFAAA56-56D3-431D-BCD4-E75A35582382}">
                       <p173:tracksInfo xmlns:p173="http://schemas.microsoft.com/office/powerpoint/2017/3/main" displayLoc="slide">
                         <p173:trackLst>
-                          <p173:track id="{B857DA69-2881-4B11-96B6-4F6D818F5FC7}" label="English (captions)" lang="en-US" r:embed="rId7"/>
+                          <p173:track id="{EA116692-9061-4428-8C18-34F71A6EAB4A}" label="English (captions)" lang="en-US" r:embed="rId7"/>
                         </p173:trackLst>
                       </p173:tracksInfo>
                     </p:ext>
@@ -11232,10 +11232,10 @@
   </p:clrMapOvr>
   <mc:AlternateContent xmlns:mc="http://schemas.openxmlformats.org/markup-compatibility/2006">
     <mc:Choice xmlns:p14="http://schemas.microsoft.com/office/powerpoint/2010/main" Requires="p14">
-      <p:transition spd="slow" p14:dur="2000" advTm="73240"/>
+      <p:transition spd="slow" p14:dur="2000" advTm="57740"/>
     </mc:Choice>
     <mc:Fallback>
-      <p:transition spd="slow" advTm="73240"/>
+      <p:transition spd="slow" advTm="57740"/>
     </mc:Fallback>
   </mc:AlternateContent>
   <p:timing>
@@ -11269,7 +11269,7 @@
                                   <p:childTnLst>
                                     <p:cmd type="call" cmd="playFrom(0.0)">
                                       <p:cBhvr>
-                                        <p:cTn id="6" dur="72240" fill="hold"/>
+                                        <p:cTn id="6" dur="53736" fill="hold"/>
                                         <p:tgtEl>
                                           <p:spTgt spid="19"/>
                                         </p:tgtEl>
@@ -13004,7 +13004,7 @@
             <a:hlinkClick r:id="" action="ppaction://media"/>
             <a:extLst>
               <a:ext uri="{FF2B5EF4-FFF2-40B4-BE49-F238E27FC236}">
-                <a16:creationId xmlns:a16="http://schemas.microsoft.com/office/drawing/2014/main" id="{C21D75C5-1097-B0AB-871C-BF67A1056536}"/>
+                <a16:creationId xmlns:a16="http://schemas.microsoft.com/office/drawing/2014/main" id="{B162AA53-323B-2E80-0465-EF37DFEF2964}"/>
               </a:ext>
             </a:extLst>
           </p:cNvPr>
@@ -13020,7 +13020,7 @@
                     <p:ext uri="{3AFAAA56-56D3-431D-BCD4-E75A35582382}">
                       <p173:tracksInfo xmlns:p173="http://schemas.microsoft.com/office/powerpoint/2017/3/main" displayLoc="slide">
                         <p173:trackLst>
-                          <p173:track id="{4FF4047C-41BE-40F9-8C1B-F69BB2F0540E}" label="English (captions)" lang="en-US" r:embed="rId8"/>
+                          <p173:track id="{A3657677-F906-4DCB-A5B0-C0335DA06403}" label="English (captions)" lang="en-US" r:embed="rId8"/>
                         </p173:trackLst>
                       </p173:tracksInfo>
                     </p:ext>
@@ -13053,10 +13053,10 @@
   </p:clrMapOvr>
   <mc:AlternateContent xmlns:mc="http://schemas.openxmlformats.org/markup-compatibility/2006">
     <mc:Choice xmlns:p14="http://schemas.microsoft.com/office/powerpoint/2010/main" Requires="p14">
-      <p:transition spd="slow" p14:dur="2000" advTm="90830"/>
+      <p:transition spd="slow" p14:dur="2000" advTm="61530"/>
     </mc:Choice>
     <mc:Fallback>
-      <p:transition spd="slow" advTm="90830"/>
+      <p:transition spd="slow" advTm="61530"/>
     </mc:Fallback>
   </mc:AlternateContent>
   <p:timing>
@@ -13090,7 +13090,7 @@
                                   <p:childTnLst>
                                     <p:cmd type="call" cmd="playFrom(0.0)">
                                       <p:cBhvr>
-                                        <p:cTn id="6" dur="89832" fill="hold"/>
+                                        <p:cTn id="6" dur="57528" fill="hold"/>
                                         <p:tgtEl>
                                           <p:spTgt spid="16"/>
                                         </p:tgtEl>
@@ -14283,7 +14283,7 @@
             <a:hlinkClick r:id="" action="ppaction://media"/>
             <a:extLst>
               <a:ext uri="{FF2B5EF4-FFF2-40B4-BE49-F238E27FC236}">
-                <a16:creationId xmlns:a16="http://schemas.microsoft.com/office/drawing/2014/main" id="{F356A936-BAEE-807C-AD60-C30E0618DEE2}"/>
+                <a16:creationId xmlns:a16="http://schemas.microsoft.com/office/drawing/2014/main" id="{E18A00F5-17AE-951A-8E69-3261B1C2EA36}"/>
               </a:ext>
             </a:extLst>
           </p:cNvPr>
@@ -14299,7 +14299,7 @@
                     <p:ext uri="{3AFAAA56-56D3-431D-BCD4-E75A35582382}">
                       <p173:tracksInfo xmlns:p173="http://schemas.microsoft.com/office/powerpoint/2017/3/main" displayLoc="slide">
                         <p173:trackLst>
-                          <p173:track id="{BB58C456-90E7-4019-932A-4A652325960B}" label="English (captions)" lang="en-US" r:embed="rId10"/>
+                          <p173:track id="{B89E4740-8E1C-4605-A6DA-D3CACFC2905F}" label="English (captions)" lang="en-US" r:embed="rId10"/>
                         </p173:trackLst>
                       </p173:tracksInfo>
                     </p:ext>
@@ -14332,10 +14332,10 @@
   </p:clrMapOvr>
   <mc:AlternateContent xmlns:mc="http://schemas.openxmlformats.org/markup-compatibility/2006">
     <mc:Choice xmlns:p14="http://schemas.microsoft.com/office/powerpoint/2010/main" Requires="p14">
-      <p:transition spd="slow" p14:dur="2000" advTm="75400"/>
+      <p:transition spd="slow" p14:dur="2000" advTm="60710"/>
     </mc:Choice>
     <mc:Fallback>
-      <p:transition spd="slow" advTm="75400"/>
+      <p:transition spd="slow" advTm="60710"/>
     </mc:Fallback>
   </mc:AlternateContent>
   <p:timing>
@@ -14369,7 +14369,7 @@
                                   <p:childTnLst>
                                     <p:cmd type="call" cmd="playFrom(0.0)">
                                       <p:cBhvr>
-                                        <p:cTn id="6" dur="74400" fill="hold"/>
+                                        <p:cTn id="6" dur="56712" fill="hold"/>
                                         <p:tgtEl>
                                           <p:spTgt spid="26"/>
                                         </p:tgtEl>
@@ -15545,7 +15545,7 @@
             <a:hlinkClick r:id="" action="ppaction://media"/>
             <a:extLst>
               <a:ext uri="{FF2B5EF4-FFF2-40B4-BE49-F238E27FC236}">
-                <a16:creationId xmlns:a16="http://schemas.microsoft.com/office/drawing/2014/main" id="{D5B15840-29F6-AB29-AA91-11376D6F3DDF}"/>
+                <a16:creationId xmlns:a16="http://schemas.microsoft.com/office/drawing/2014/main" id="{74370BF2-7285-7FF2-8A49-82D03EE2BD84}"/>
               </a:ext>
             </a:extLst>
           </p:cNvPr>
@@ -15561,7 +15561,7 @@
                     <p:ext uri="{3AFAAA56-56D3-431D-BCD4-E75A35582382}">
                       <p173:tracksInfo xmlns:p173="http://schemas.microsoft.com/office/powerpoint/2017/3/main" displayLoc="slide">
                         <p173:trackLst>
-                          <p173:track id="{85479FBA-7693-4A5F-BC06-4F97083406D3}" label="English (captions)" lang="en-US" r:embed="rId7"/>
+                          <p173:track id="{DF4B0695-B0AB-406B-8D28-3256E33261ED}" label="English (captions)" lang="en-US" r:embed="rId7"/>
                         </p173:trackLst>
                       </p173:tracksInfo>
                     </p:ext>
@@ -15594,10 +15594,10 @@
   </p:clrMapOvr>
   <mc:AlternateContent xmlns:mc="http://schemas.openxmlformats.org/markup-compatibility/2006">
     <mc:Choice xmlns:p14="http://schemas.microsoft.com/office/powerpoint/2010/main" Requires="p14">
-      <p:transition spd="slow" p14:dur="2000" advTm="78140"/>
+      <p:transition spd="slow" p14:dur="2000" advTm="60230"/>
     </mc:Choice>
     <mc:Fallback>
-      <p:transition spd="slow" advTm="78140"/>
+      <p:transition spd="slow" advTm="60230"/>
     </mc:Fallback>
   </mc:AlternateContent>
   <p:timing>
@@ -15631,7 +15631,7 @@
                                   <p:childTnLst>
                                     <p:cmd type="call" cmd="playFrom(0.0)">
                                       <p:cBhvr>
-                                        <p:cTn id="6" dur="77136" fill="hold"/>
+                                        <p:cTn id="6" dur="56232" fill="hold"/>
                                         <p:tgtEl>
                                           <p:spTgt spid="26"/>
                                         </p:tgtEl>

</xml_diff>